<commit_message>
Rebrand LinkedIn carousel to the live site's actual UI (Botanical Ink palette, real logo mark)
Co-Authored-By: Claude Sonnet 5 <noreply@anthropic.com>
Claude-Session: https://claude.ai/code/session_01RP8rCVarvEGjpHDYnFJ3xW
</commit_message>
<xml_diff>
--- a/linkedin-carousel.pptx
+++ b/linkedin-carousel.pptx
@@ -1658,7 +1658,7 @@
     <p:bg>
       <p:bgPr>
         <a:solidFill>
-          <a:srgbClr val="141A35"/>
+          <a:srgbClr val="14201A"/>
         </a:solidFill>
       </p:bgPr>
     </p:bg>
@@ -1684,167 +1684,51 @@
         </p:nvSpPr>
         <p:spPr>
           <a:xfrm>
-            <a:off x="822960" y="914400"/>
-            <a:ext cx="137160" cy="137160"/>
-          </a:xfrm>
-          <a:prstGeom prst="star5">
+            <a:off x="3200400" y="1143000"/>
+            <a:ext cx="914400" cy="914400"/>
+          </a:xfrm>
+          <a:prstGeom prst="ellipse">
             <a:avLst/>
           </a:prstGeom>
           <a:solidFill>
-            <a:srgbClr val="39406E"/>
+            <a:srgbClr val="1C2A20"/>
           </a:solidFill>
           <a:ln/>
         </p:spPr>
       </p:sp>
-      <p:sp>
-        <p:nvSpPr>
-          <p:cNvPr id="3" name="Shape 1"/>
-          <p:cNvSpPr/>
-          <p:nvPr/>
-        </p:nvSpPr>
-        <p:spPr>
-          <a:xfrm>
-            <a:off x="6492240" y="1371600"/>
-            <a:ext cx="109728" cy="109728"/>
-          </a:xfrm>
-          <a:prstGeom prst="star5">
-            <a:avLst/>
-          </a:prstGeom>
-          <a:solidFill>
-            <a:srgbClr val="39406E"/>
-          </a:solidFill>
-          <a:ln/>
-        </p:spPr>
-      </p:sp>
-      <p:sp>
-        <p:nvSpPr>
-          <p:cNvPr id="4" name="Shape 2"/>
-          <p:cNvSpPr/>
-          <p:nvPr/>
-        </p:nvSpPr>
-        <p:spPr>
-          <a:xfrm>
-            <a:off x="1188720" y="7863840"/>
-            <a:ext cx="123444" cy="123444"/>
-          </a:xfrm>
-          <a:prstGeom prst="star5">
-            <a:avLst/>
-          </a:prstGeom>
-          <a:solidFill>
-            <a:srgbClr val="39406E"/>
-          </a:solidFill>
-          <a:ln/>
-        </p:spPr>
-      </p:sp>
-      <p:sp>
-        <p:nvSpPr>
-          <p:cNvPr id="5" name="Shape 3"/>
-          <p:cNvSpPr/>
-          <p:nvPr/>
-        </p:nvSpPr>
-        <p:spPr>
-          <a:xfrm>
-            <a:off x="6035040" y="7498080"/>
-            <a:ext cx="137160" cy="137160"/>
-          </a:xfrm>
-          <a:prstGeom prst="star5">
-            <a:avLst/>
-          </a:prstGeom>
-          <a:solidFill>
-            <a:srgbClr val="39406E"/>
-          </a:solidFill>
-          <a:ln/>
-        </p:spPr>
-      </p:sp>
-      <p:sp>
-        <p:nvSpPr>
-          <p:cNvPr id="6" name="Shape 4"/>
-          <p:cNvSpPr/>
-          <p:nvPr/>
-        </p:nvSpPr>
-        <p:spPr>
-          <a:xfrm>
-            <a:off x="548640" y="3931920"/>
-            <a:ext cx="96012" cy="96012"/>
-          </a:xfrm>
-          <a:prstGeom prst="star5">
-            <a:avLst/>
-          </a:prstGeom>
-          <a:solidFill>
-            <a:srgbClr val="39406E"/>
-          </a:solidFill>
-          <a:ln/>
-        </p:spPr>
-      </p:sp>
-      <p:sp>
-        <p:nvSpPr>
-          <p:cNvPr id="7" name="Shape 5"/>
-          <p:cNvSpPr/>
-          <p:nvPr/>
-        </p:nvSpPr>
-        <p:spPr>
-          <a:xfrm>
-            <a:off x="6766560" y="4480560"/>
-            <a:ext cx="109728" cy="109728"/>
-          </a:xfrm>
-          <a:prstGeom prst="star5">
-            <a:avLst/>
-          </a:prstGeom>
-          <a:solidFill>
-            <a:srgbClr val="39406E"/>
-          </a:solidFill>
-          <a:ln/>
-        </p:spPr>
-      </p:sp>
-      <p:sp>
-        <p:nvSpPr>
-          <p:cNvPr id="8" name="Shape 6"/>
-          <p:cNvSpPr/>
-          <p:nvPr/>
-        </p:nvSpPr>
-        <p:spPr>
-          <a:xfrm>
-            <a:off x="3246120" y="1234440"/>
-            <a:ext cx="822960" cy="822960"/>
-          </a:xfrm>
-          <a:prstGeom prst="ellipse">
-            <a:avLst/>
-          </a:prstGeom>
-          <a:solidFill>
-            <a:srgbClr val="C89B3C"/>
-          </a:solidFill>
-          <a:ln/>
-        </p:spPr>
-      </p:sp>
-      <p:sp>
-        <p:nvSpPr>
-          <p:cNvPr id="9" name="Shape 7"/>
-          <p:cNvSpPr/>
-          <p:nvPr/>
-        </p:nvSpPr>
-        <p:spPr>
-          <a:xfrm>
-            <a:off x="3468319" y="1456639"/>
-            <a:ext cx="378562" cy="378562"/>
-          </a:xfrm>
-          <a:prstGeom prst="star5">
-            <a:avLst/>
-          </a:prstGeom>
-          <a:solidFill>
-            <a:srgbClr val="141A35"/>
-          </a:solidFill>
-          <a:ln/>
-        </p:spPr>
-      </p:sp>
-      <p:sp>
-        <p:nvSpPr>
-          <p:cNvPr id="10" name="Text 8"/>
-          <p:cNvSpPr txBox="1"/>
-          <p:nvPr/>
-        </p:nvSpPr>
-        <p:spPr>
-          <a:xfrm>
-            <a:off x="548640" y="2331720"/>
+      <p:pic>
+        <p:nvPicPr>
+          <p:cNvPr id="3" name="Image 0" descr="mark-ondark.png">    </p:cNvPr>
+          <p:cNvPicPr>
+            <a:picLocks noChangeAspect="1"/>
+          </p:cNvPicPr>
+          <p:nvPr/>
+        </p:nvPicPr>
+        <p:blipFill>
+          <a:blip r:embed="rId1"/>
+          <a:stretch>
+            <a:fillRect/>
+          </a:stretch>
+        </p:blipFill>
+        <p:spPr>
+          <a:xfrm>
+            <a:off x="3401568" y="1344168"/>
+            <a:ext cx="512064" cy="512064"/>
+          </a:xfrm>
+          <a:prstGeom prst="rect">
+            <a:avLst/>
+          </a:prstGeom>
+        </p:spPr>
+      </p:pic>
+      <p:sp>
+        <p:nvSpPr>
+          <p:cNvPr id="4" name="Text 1"/>
+          <p:cNvSpPr txBox="1"/>
+          <p:nvPr/>
+        </p:nvSpPr>
+        <p:spPr>
+          <a:xfrm>
+            <a:off x="548640" y="2286000"/>
             <a:ext cx="6217920" cy="365760"/>
           </a:xfrm>
           <a:prstGeom prst="rect">
@@ -1863,7 +1747,7 @@
             <a:r>
               <a:rPr lang="en-US" sz="1300" b="1" spc="300" kern="0" dirty="0">
                 <a:solidFill>
-                  <a:srgbClr val="E6D6A8"/>
+                  <a:srgbClr val="C25F3D"/>
                 </a:solidFill>
                 <a:latin typeface="Calibri" pitchFamily="34" charset="0"/>
                 <a:ea typeface="Calibri" pitchFamily="34" charset="-122"/>
@@ -1877,13 +1761,13 @@
       </p:sp>
       <p:sp>
         <p:nvSpPr>
-          <p:cNvPr id="11" name="Text 9"/>
-          <p:cNvSpPr txBox="1"/>
-          <p:nvPr/>
-        </p:nvSpPr>
-        <p:spPr>
-          <a:xfrm>
-            <a:off x="548640" y="2834640"/>
+          <p:cNvPr id="5" name="Text 2"/>
+          <p:cNvSpPr txBox="1"/>
+          <p:nvPr/>
+        </p:nvSpPr>
+        <p:spPr>
+          <a:xfrm>
+            <a:off x="548640" y="2788920"/>
             <a:ext cx="6217920" cy="2743200"/>
           </a:xfrm>
           <a:prstGeom prst="rect">
@@ -1905,7 +1789,7 @@
             <a:r>
               <a:rPr lang="en-US" sz="3800" b="1" dirty="0">
                 <a:solidFill>
-                  <a:srgbClr val="FFFFFF"/>
+                  <a:srgbClr val="F2EAD6"/>
                 </a:solidFill>
                 <a:latin typeface="Cambria" pitchFamily="34" charset="0"/>
                 <a:ea typeface="Cambria" pitchFamily="34" charset="-122"/>
@@ -1925,7 +1809,7 @@
             <a:r>
               <a:rPr lang="en-US" sz="3800" b="1" dirty="0">
                 <a:solidFill>
-                  <a:srgbClr val="FFFFFF"/>
+                  <a:srgbClr val="F2EAD6"/>
                 </a:solidFill>
                 <a:latin typeface="Cambria" pitchFamily="34" charset="0"/>
                 <a:ea typeface="Cambria" pitchFamily="34" charset="-122"/>
@@ -1945,7 +1829,7 @@
             <a:r>
               <a:rPr lang="en-US" sz="3800" b="1" dirty="0">
                 <a:solidFill>
-                  <a:srgbClr val="FFFFFF"/>
+                  <a:srgbClr val="F2EAD6"/>
                 </a:solidFill>
                 <a:latin typeface="Cambria" pitchFamily="34" charset="0"/>
                 <a:ea typeface="Cambria" pitchFamily="34" charset="-122"/>
@@ -1959,13 +1843,13 @@
       </p:sp>
       <p:sp>
         <p:nvSpPr>
-          <p:cNvPr id="12" name="Text 10"/>
-          <p:cNvSpPr txBox="1"/>
-          <p:nvPr/>
-        </p:nvSpPr>
-        <p:spPr>
-          <a:xfrm>
-            <a:off x="822960" y="5806440"/>
+          <p:cNvPr id="6" name="Text 3"/>
+          <p:cNvSpPr txBox="1"/>
+          <p:nvPr/>
+        </p:nvSpPr>
+        <p:spPr>
+          <a:xfrm>
+            <a:off x="822960" y="5760720"/>
             <a:ext cx="5669280" cy="822960"/>
           </a:xfrm>
           <a:prstGeom prst="rect">
@@ -1987,7 +1871,7 @@
             <a:r>
               <a:rPr lang="en-US" sz="1500" dirty="0">
                 <a:solidFill>
-                  <a:srgbClr val="E9E7F5"/>
+                  <a:srgbClr val="D8CFB8"/>
                 </a:solidFill>
                 <a:latin typeface="Calibri" pitchFamily="34" charset="0"/>
                 <a:ea typeface="Calibri" pitchFamily="34" charset="-122"/>
@@ -2007,7 +1891,7 @@
             <a:r>
               <a:rPr lang="en-US" sz="1500" dirty="0">
                 <a:solidFill>
-                  <a:srgbClr val="E9E7F5"/>
+                  <a:srgbClr val="D8CFB8"/>
                 </a:solidFill>
                 <a:latin typeface="Calibri" pitchFamily="34" charset="0"/>
                 <a:ea typeface="Calibri" pitchFamily="34" charset="-122"/>
@@ -2021,7 +1905,7 @@
       </p:sp>
       <p:sp>
         <p:nvSpPr>
-          <p:cNvPr id="13" name="Text 11"/>
+          <p:cNvPr id="7" name="Text 4"/>
           <p:cNvSpPr txBox="1"/>
           <p:nvPr/>
         </p:nvSpPr>
@@ -2046,7 +1930,7 @@
             <a:r>
               <a:rPr lang="en-US" sz="1300" b="1" spc="300" kern="0" dirty="0">
                 <a:solidFill>
-                  <a:srgbClr val="C89B3C"/>
+                  <a:srgbClr val="C25F3D"/>
                 </a:solidFill>
                 <a:latin typeface="Calibri" pitchFamily="34" charset="0"/>
                 <a:ea typeface="Calibri" pitchFamily="34" charset="-122"/>
@@ -2060,7 +1944,7 @@
       </p:sp>
       <p:sp>
         <p:nvSpPr>
-          <p:cNvPr id="14" name="Text 12"/>
+          <p:cNvPr id="8" name="Text 5"/>
           <p:cNvSpPr txBox="1"/>
           <p:nvPr/>
         </p:nvSpPr>
@@ -2085,7 +1969,7 @@
             <a:r>
               <a:rPr lang="en-US" sz="1000" dirty="0">
                 <a:solidFill>
-                  <a:srgbClr val="7B81AE"/>
+                  <a:srgbClr val="9AA894"/>
                 </a:solidFill>
                 <a:latin typeface="Calibri" pitchFamily="34" charset="0"/>
                 <a:ea typeface="Calibri" pitchFamily="34" charset="-122"/>
@@ -2111,7 +1995,7 @@
     <p:bg>
       <p:bgPr>
         <a:solidFill>
-          <a:srgbClr val="141A35"/>
+          <a:srgbClr val="14201A"/>
         </a:solidFill>
       </p:bgPr>
     </p:bg>
@@ -2137,47 +2021,51 @@
         </p:nvSpPr>
         <p:spPr>
           <a:xfrm>
-            <a:off x="3246120" y="1005840"/>
-            <a:ext cx="822960" cy="822960"/>
+            <a:off x="3200400" y="960120"/>
+            <a:ext cx="914400" cy="914400"/>
           </a:xfrm>
           <a:prstGeom prst="ellipse">
             <a:avLst/>
           </a:prstGeom>
           <a:solidFill>
-            <a:srgbClr val="C89B3C"/>
+            <a:srgbClr val="1C2A20"/>
           </a:solidFill>
           <a:ln/>
         </p:spPr>
       </p:sp>
-      <p:sp>
-        <p:nvSpPr>
-          <p:cNvPr id="3" name="Shape 1"/>
-          <p:cNvSpPr/>
-          <p:nvPr/>
-        </p:nvSpPr>
-        <p:spPr>
-          <a:xfrm>
-            <a:off x="3468319" y="1228039"/>
-            <a:ext cx="378562" cy="378562"/>
-          </a:xfrm>
-          <a:prstGeom prst="star5">
-            <a:avLst/>
-          </a:prstGeom>
-          <a:solidFill>
-            <a:srgbClr val="141A35"/>
-          </a:solidFill>
-          <a:ln/>
-        </p:spPr>
-      </p:sp>
-      <p:sp>
-        <p:nvSpPr>
-          <p:cNvPr id="4" name="Text 2"/>
-          <p:cNvSpPr txBox="1"/>
-          <p:nvPr/>
-        </p:nvSpPr>
-        <p:spPr>
-          <a:xfrm>
-            <a:off x="548640" y="2286000"/>
+      <p:pic>
+        <p:nvPicPr>
+          <p:cNvPr id="3" name="Image 0" descr="mark-ondark.png">    </p:cNvPr>
+          <p:cNvPicPr>
+            <a:picLocks noChangeAspect="1"/>
+          </p:cNvPicPr>
+          <p:nvPr/>
+        </p:nvPicPr>
+        <p:blipFill>
+          <a:blip r:embed="rId1"/>
+          <a:stretch>
+            <a:fillRect/>
+          </a:stretch>
+        </p:blipFill>
+        <p:spPr>
+          <a:xfrm>
+            <a:off x="3401568" y="1161288"/>
+            <a:ext cx="512064" cy="512064"/>
+          </a:xfrm>
+          <a:prstGeom prst="rect">
+            <a:avLst/>
+          </a:prstGeom>
+        </p:spPr>
+      </p:pic>
+      <p:sp>
+        <p:nvSpPr>
+          <p:cNvPr id="4" name="Text 1"/>
+          <p:cNvSpPr txBox="1"/>
+          <p:nvPr/>
+        </p:nvSpPr>
+        <p:spPr>
+          <a:xfrm>
+            <a:off x="548640" y="2240280"/>
             <a:ext cx="6217920" cy="640080"/>
           </a:xfrm>
           <a:prstGeom prst="rect">
@@ -2196,7 +2084,7 @@
             <a:r>
               <a:rPr lang="en-US" sz="3000" b="1" dirty="0">
                 <a:solidFill>
-                  <a:srgbClr val="FFFFFF"/>
+                  <a:srgbClr val="F2EAD6"/>
                 </a:solidFill>
                 <a:latin typeface="Cambria" pitchFamily="34" charset="0"/>
                 <a:ea typeface="Cambria" pitchFamily="34" charset="-122"/>
@@ -2210,13 +2098,13 @@
       </p:sp>
       <p:sp>
         <p:nvSpPr>
-          <p:cNvPr id="5" name="Text 3"/>
-          <p:cNvSpPr txBox="1"/>
-          <p:nvPr/>
-        </p:nvSpPr>
-        <p:spPr>
-          <a:xfrm>
-            <a:off x="822960" y="3063240"/>
+          <p:cNvPr id="5" name="Text 2"/>
+          <p:cNvSpPr txBox="1"/>
+          <p:nvPr/>
+        </p:nvSpPr>
+        <p:spPr>
+          <a:xfrm>
+            <a:off x="822960" y="3017520"/>
             <a:ext cx="5669280" cy="1097280"/>
           </a:xfrm>
           <a:prstGeom prst="rect">
@@ -2238,7 +2126,7 @@
             <a:r>
               <a:rPr lang="en-US" sz="1450" dirty="0">
                 <a:solidFill>
-                  <a:srgbClr val="E9E7F5"/>
+                  <a:srgbClr val="D8CFB8"/>
                 </a:solidFill>
                 <a:latin typeface="Calibri" pitchFamily="34" charset="0"/>
                 <a:ea typeface="Calibri" pitchFamily="34" charset="-122"/>
@@ -2258,7 +2146,7 @@
             <a:r>
               <a:rPr lang="en-US" sz="1450" dirty="0">
                 <a:solidFill>
-                  <a:srgbClr val="E9E7F5"/>
+                  <a:srgbClr val="D8CFB8"/>
                 </a:solidFill>
                 <a:latin typeface="Calibri" pitchFamily="34" charset="0"/>
                 <a:ea typeface="Calibri" pitchFamily="34" charset="-122"/>
@@ -2278,7 +2166,7 @@
             <a:r>
               <a:rPr lang="en-US" sz="1450" dirty="0">
                 <a:solidFill>
-                  <a:srgbClr val="E9E7F5"/>
+                  <a:srgbClr val="D8CFB8"/>
                 </a:solidFill>
                 <a:latin typeface="Calibri" pitchFamily="34" charset="0"/>
                 <a:ea typeface="Calibri" pitchFamily="34" charset="-122"/>
@@ -2292,26 +2180,26 @@
       </p:sp>
       <p:sp>
         <p:nvSpPr>
-          <p:cNvPr id="6" name="Shape 4"/>
+          <p:cNvPr id="6" name="Shape 3"/>
           <p:cNvSpPr/>
           <p:nvPr/>
         </p:nvSpPr>
         <p:spPr>
           <a:xfrm>
-            <a:off x="1005840" y="4526280"/>
+            <a:off x="1005840" y="4480560"/>
             <a:ext cx="5303520" cy="1051560"/>
           </a:xfrm>
           <a:prstGeom prst="roundRect">
             <a:avLst>
-              <a:gd name="adj" fmla="val 8696"/>
+              <a:gd name="adj" fmla="val 5217"/>
             </a:avLst>
           </a:prstGeom>
           <a:solidFill>
-            <a:srgbClr val="1E2555"/>
+            <a:srgbClr val="1C2A20"/>
           </a:solidFill>
           <a:ln w="12700">
             <a:solidFill>
-              <a:srgbClr val="3A4079"/>
+              <a:srgbClr val="35462F"/>
             </a:solidFill>
             <a:prstDash val="solid"/>
           </a:ln>
@@ -2319,13 +2207,13 @@
       </p:sp>
       <p:sp>
         <p:nvSpPr>
-          <p:cNvPr id="7" name="Text 5"/>
-          <p:cNvSpPr txBox="1"/>
-          <p:nvPr/>
-        </p:nvSpPr>
-        <p:spPr>
-          <a:xfrm>
-            <a:off x="1005840" y="4754880"/>
+          <p:cNvPr id="7" name="Text 4"/>
+          <p:cNvSpPr txBox="1"/>
+          <p:nvPr/>
+        </p:nvSpPr>
+        <p:spPr>
+          <a:xfrm>
+            <a:off x="1005840" y="4709160"/>
             <a:ext cx="5303520" cy="365760"/>
           </a:xfrm>
           <a:prstGeom prst="rect">
@@ -2344,7 +2232,7 @@
             <a:r>
               <a:rPr lang="en-US" sz="1600" b="1" dirty="0">
                 <a:solidFill>
-                  <a:srgbClr val="C89B3C"/>
+                  <a:srgbClr val="C25F3D"/>
                 </a:solidFill>
                 <a:latin typeface="Calibri" pitchFamily="34" charset="0"/>
                 <a:ea typeface="Calibri" pitchFamily="34" charset="-122"/>
@@ -2358,13 +2246,13 @@
       </p:sp>
       <p:sp>
         <p:nvSpPr>
-          <p:cNvPr id="8" name="Text 6"/>
-          <p:cNvSpPr txBox="1"/>
-          <p:nvPr/>
-        </p:nvSpPr>
-        <p:spPr>
-          <a:xfrm>
-            <a:off x="1005840" y="5120640"/>
+          <p:cNvPr id="8" name="Text 5"/>
+          <p:cNvSpPr txBox="1"/>
+          <p:nvPr/>
+        </p:nvSpPr>
+        <p:spPr>
+          <a:xfrm>
+            <a:off x="1005840" y="5074920"/>
             <a:ext cx="5303520" cy="365760"/>
           </a:xfrm>
           <a:prstGeom prst="rect">
@@ -2383,7 +2271,7 @@
             <a:r>
               <a:rPr lang="en-US" sz="1200" dirty="0">
                 <a:solidFill>
-                  <a:srgbClr val="E9E7F5"/>
+                  <a:srgbClr val="D8CFB8"/>
                 </a:solidFill>
                 <a:latin typeface="Calibri" pitchFamily="34" charset="0"/>
                 <a:ea typeface="Calibri" pitchFamily="34" charset="-122"/>
@@ -2397,13 +2285,13 @@
       </p:sp>
       <p:sp>
         <p:nvSpPr>
-          <p:cNvPr id="9" name="Text 7"/>
-          <p:cNvSpPr txBox="1"/>
-          <p:nvPr/>
-        </p:nvSpPr>
-        <p:spPr>
-          <a:xfrm>
-            <a:off x="822960" y="6035040"/>
+          <p:cNvPr id="9" name="Text 6"/>
+          <p:cNvSpPr txBox="1"/>
+          <p:nvPr/>
+        </p:nvSpPr>
+        <p:spPr>
+          <a:xfrm>
+            <a:off x="822960" y="5989320"/>
             <a:ext cx="5669280" cy="822960"/>
           </a:xfrm>
           <a:prstGeom prst="rect">
@@ -2425,7 +2313,7 @@
             <a:r>
               <a:rPr lang="en-US" sz="1400" i="1" dirty="0">
                 <a:solidFill>
-                  <a:srgbClr val="E9E7F5"/>
+                  <a:srgbClr val="D8CFB8"/>
                 </a:solidFill>
                 <a:latin typeface="Calibri" pitchFamily="34" charset="0"/>
                 <a:ea typeface="Calibri" pitchFamily="34" charset="-122"/>
@@ -2445,7 +2333,7 @@
             <a:r>
               <a:rPr lang="en-US" sz="1400" i="1" dirty="0">
                 <a:solidFill>
-                  <a:srgbClr val="E9E7F5"/>
+                  <a:srgbClr val="D8CFB8"/>
                 </a:solidFill>
                 <a:latin typeface="Calibri" pitchFamily="34" charset="0"/>
                 <a:ea typeface="Calibri" pitchFamily="34" charset="-122"/>
@@ -2459,7 +2347,7 @@
       </p:sp>
       <p:sp>
         <p:nvSpPr>
-          <p:cNvPr id="10" name="Text 8"/>
+          <p:cNvPr id="10" name="Text 7"/>
           <p:cNvSpPr txBox="1"/>
           <p:nvPr/>
         </p:nvSpPr>
@@ -2484,7 +2372,7 @@
             <a:r>
               <a:rPr lang="en-US" sz="1150" dirty="0">
                 <a:solidFill>
-                  <a:srgbClr val="E6D6A8"/>
+                  <a:srgbClr val="C25F3D"/>
                 </a:solidFill>
                 <a:latin typeface="Calibri" pitchFamily="34" charset="0"/>
                 <a:ea typeface="Calibri" pitchFamily="34" charset="-122"/>
@@ -2498,7 +2386,7 @@
       </p:sp>
       <p:sp>
         <p:nvSpPr>
-          <p:cNvPr id="11" name="Text 9"/>
+          <p:cNvPr id="11" name="Text 8"/>
           <p:cNvSpPr txBox="1"/>
           <p:nvPr/>
         </p:nvSpPr>
@@ -2523,7 +2411,7 @@
             <a:r>
               <a:rPr lang="en-US" sz="1000" dirty="0">
                 <a:solidFill>
-                  <a:srgbClr val="7B81AE"/>
+                  <a:srgbClr val="9AA894"/>
                 </a:solidFill>
                 <a:latin typeface="Calibri" pitchFamily="34" charset="0"/>
                 <a:ea typeface="Calibri" pitchFamily="34" charset="-122"/>
@@ -2549,7 +2437,7 @@
     <p:bg>
       <p:bgPr>
         <a:solidFill>
-          <a:srgbClr val="EDEBF8"/>
+          <a:srgbClr val="F2EAD6"/>
         </a:solidFill>
       </p:bgPr>
     </p:bg>
@@ -2582,34 +2470,38 @@
             <a:avLst/>
           </a:prstGeom>
           <a:solidFill>
-            <a:srgbClr val="C89B3C"/>
+            <a:srgbClr val="E7ECE5"/>
           </a:solidFill>
           <a:ln/>
         </p:spPr>
       </p:sp>
-      <p:sp>
-        <p:nvSpPr>
-          <p:cNvPr id="3" name="Shape 1"/>
-          <p:cNvSpPr/>
-          <p:nvPr/>
-        </p:nvSpPr>
-        <p:spPr>
-          <a:xfrm>
-            <a:off x="672084" y="672084"/>
-            <a:ext cx="210312" cy="210312"/>
-          </a:xfrm>
-          <a:prstGeom prst="star5">
-            <a:avLst/>
-          </a:prstGeom>
-          <a:solidFill>
-            <a:srgbClr val="141A35"/>
-          </a:solidFill>
-          <a:ln/>
-        </p:spPr>
-      </p:sp>
-      <p:sp>
-        <p:nvSpPr>
-          <p:cNvPr id="4" name="Text 2"/>
+      <p:pic>
+        <p:nvPicPr>
+          <p:cNvPr id="3" name="Image 0" descr="mark-onlight.png">    </p:cNvPr>
+          <p:cNvPicPr>
+            <a:picLocks noChangeAspect="1"/>
+          </p:cNvPicPr>
+          <p:nvPr/>
+        </p:nvPicPr>
+        <p:blipFill>
+          <a:blip r:embed="rId1"/>
+          <a:stretch>
+            <a:fillRect/>
+          </a:stretch>
+        </p:blipFill>
+        <p:spPr>
+          <a:xfrm>
+            <a:off x="649224" y="649224"/>
+            <a:ext cx="256032" cy="256032"/>
+          </a:xfrm>
+          <a:prstGeom prst="rect">
+            <a:avLst/>
+          </a:prstGeom>
+        </p:spPr>
+      </p:pic>
+      <p:sp>
+        <p:nvSpPr>
+          <p:cNvPr id="4" name="Text 1"/>
           <p:cNvSpPr txBox="1"/>
           <p:nvPr/>
         </p:nvSpPr>
@@ -2634,7 +2526,7 @@
             <a:r>
               <a:rPr lang="en-US" sz="1200" b="1" spc="200" kern="0" dirty="0">
                 <a:solidFill>
-                  <a:srgbClr val="C89B3C"/>
+                  <a:srgbClr val="A8452A"/>
                 </a:solidFill>
                 <a:latin typeface="Calibri" pitchFamily="34" charset="0"/>
                 <a:ea typeface="Calibri" pitchFamily="34" charset="-122"/>
@@ -2648,7 +2540,7 @@
       </p:sp>
       <p:sp>
         <p:nvSpPr>
-          <p:cNvPr id="5" name="Text 3"/>
+          <p:cNvPr id="5" name="Text 2"/>
           <p:cNvSpPr txBox="1"/>
           <p:nvPr/>
         </p:nvSpPr>
@@ -2676,7 +2568,7 @@
             <a:r>
               <a:rPr lang="en-US" sz="3000" b="1" dirty="0">
                 <a:solidFill>
-                  <a:srgbClr val="141A35"/>
+                  <a:srgbClr val="253B2C"/>
                 </a:solidFill>
                 <a:latin typeface="Cambria" pitchFamily="34" charset="0"/>
                 <a:ea typeface="Cambria" pitchFamily="34" charset="-122"/>
@@ -2696,7 +2588,7 @@
             <a:r>
               <a:rPr lang="en-US" sz="3000" b="1" dirty="0">
                 <a:solidFill>
-                  <a:srgbClr val="141A35"/>
+                  <a:srgbClr val="253B2C"/>
                 </a:solidFill>
                 <a:latin typeface="Cambria" pitchFamily="34" charset="0"/>
                 <a:ea typeface="Cambria" pitchFamily="34" charset="-122"/>
@@ -2710,7 +2602,7 @@
       </p:sp>
       <p:sp>
         <p:nvSpPr>
-          <p:cNvPr id="6" name="Shape 4"/>
+          <p:cNvPr id="6" name="Shape 3"/>
           <p:cNvSpPr/>
           <p:nvPr/>
         </p:nvSpPr>
@@ -2721,17 +2613,17 @@
           </a:xfrm>
           <a:prstGeom prst="roundRect">
             <a:avLst>
-              <a:gd name="adj" fmla="val 4800"/>
+              <a:gd name="adj" fmla="val 2400"/>
             </a:avLst>
           </a:prstGeom>
           <a:solidFill>
-            <a:srgbClr val="141A35"/>
+            <a:srgbClr val="14201A"/>
           </a:solidFill>
           <a:ln/>
           <a:effectLst>
             <a:outerShdw sx="100000" sy="100000" kx="0" ky="0" algn="bl" rotWithShape="0" blurRad="127000" dist="38100" dir="5400000">
-              <a:srgbClr val="8C90B8">
-                <a:alpha val="35000"/>
+              <a:srgbClr val="8A7C6C">
+                <a:alpha val="30000"/>
               </a:srgbClr>
             </a:outerShdw>
           </a:effectLst>
@@ -2739,7 +2631,7 @@
       </p:sp>
       <p:sp>
         <p:nvSpPr>
-          <p:cNvPr id="7" name="Text 5"/>
+          <p:cNvPr id="7" name="Text 4"/>
           <p:cNvSpPr txBox="1"/>
           <p:nvPr/>
         </p:nvSpPr>
@@ -2764,7 +2656,7 @@
             <a:r>
               <a:rPr lang="en-US" sz="7800" b="1" dirty="0">
                 <a:solidFill>
-                  <a:srgbClr val="C89B3C"/>
+                  <a:srgbClr val="C25F3D"/>
                 </a:solidFill>
                 <a:latin typeface="Cambria" pitchFamily="34" charset="0"/>
                 <a:ea typeface="Cambria" pitchFamily="34" charset="-122"/>
@@ -2778,7 +2670,7 @@
       </p:sp>
       <p:sp>
         <p:nvSpPr>
-          <p:cNvPr id="8" name="Text 6"/>
+          <p:cNvPr id="8" name="Text 5"/>
           <p:cNvSpPr txBox="1"/>
           <p:nvPr/>
         </p:nvSpPr>
@@ -2803,7 +2695,7 @@
             <a:r>
               <a:rPr lang="en-US" sz="1300" b="1" spc="200" kern="0" dirty="0">
                 <a:solidFill>
-                  <a:srgbClr val="E9E7F5"/>
+                  <a:srgbClr val="D8CFB8"/>
                 </a:solidFill>
                 <a:latin typeface="Calibri" pitchFamily="34" charset="0"/>
                 <a:ea typeface="Calibri" pitchFamily="34" charset="-122"/>
@@ -2817,7 +2709,7 @@
       </p:sp>
       <p:sp>
         <p:nvSpPr>
-          <p:cNvPr id="9" name="Shape 7"/>
+          <p:cNvPr id="9" name="Shape 6"/>
           <p:cNvSpPr/>
           <p:nvPr/>
         </p:nvSpPr>
@@ -2830,14 +2722,14 @@
             <a:avLst/>
           </a:prstGeom>
           <a:solidFill>
-            <a:srgbClr val="C89B3C"/>
+            <a:srgbClr val="A8452A"/>
           </a:solidFill>
           <a:ln/>
         </p:spPr>
       </p:sp>
       <p:sp>
         <p:nvSpPr>
-          <p:cNvPr id="10" name="Text 8"/>
+          <p:cNvPr id="10" name="Text 7"/>
           <p:cNvSpPr txBox="1"/>
           <p:nvPr/>
         </p:nvSpPr>
@@ -2865,7 +2757,7 @@
             <a:r>
               <a:rPr lang="en-US" sz="1450" dirty="0">
                 <a:solidFill>
-                  <a:srgbClr val="2B2F4A"/>
+                  <a:srgbClr val="201D16"/>
                 </a:solidFill>
                 <a:latin typeface="Calibri" pitchFamily="34" charset="0"/>
                 <a:ea typeface="Calibri" pitchFamily="34" charset="-122"/>
@@ -2879,7 +2771,7 @@
       </p:sp>
       <p:sp>
         <p:nvSpPr>
-          <p:cNvPr id="11" name="Shape 9"/>
+          <p:cNvPr id="11" name="Shape 8"/>
           <p:cNvSpPr/>
           <p:nvPr/>
         </p:nvSpPr>
@@ -2892,14 +2784,14 @@
             <a:avLst/>
           </a:prstGeom>
           <a:solidFill>
-            <a:srgbClr val="C89B3C"/>
+            <a:srgbClr val="A8452A"/>
           </a:solidFill>
           <a:ln/>
         </p:spPr>
       </p:sp>
       <p:sp>
         <p:nvSpPr>
-          <p:cNvPr id="12" name="Text 10"/>
+          <p:cNvPr id="12" name="Text 9"/>
           <p:cNvSpPr txBox="1"/>
           <p:nvPr/>
         </p:nvSpPr>
@@ -2927,7 +2819,7 @@
             <a:r>
               <a:rPr lang="en-US" sz="1450" dirty="0">
                 <a:solidFill>
-                  <a:srgbClr val="2B2F4A"/>
+                  <a:srgbClr val="201D16"/>
                 </a:solidFill>
                 <a:latin typeface="Calibri" pitchFamily="34" charset="0"/>
                 <a:ea typeface="Calibri" pitchFamily="34" charset="-122"/>
@@ -2941,7 +2833,7 @@
       </p:sp>
       <p:sp>
         <p:nvSpPr>
-          <p:cNvPr id="13" name="Shape 11"/>
+          <p:cNvPr id="13" name="Shape 10"/>
           <p:cNvSpPr/>
           <p:nvPr/>
         </p:nvSpPr>
@@ -2954,14 +2846,14 @@
             <a:avLst/>
           </a:prstGeom>
           <a:solidFill>
-            <a:srgbClr val="C89B3C"/>
+            <a:srgbClr val="A8452A"/>
           </a:solidFill>
           <a:ln/>
         </p:spPr>
       </p:sp>
       <p:sp>
         <p:nvSpPr>
-          <p:cNvPr id="14" name="Text 12"/>
+          <p:cNvPr id="14" name="Text 11"/>
           <p:cNvSpPr txBox="1"/>
           <p:nvPr/>
         </p:nvSpPr>
@@ -2989,7 +2881,7 @@
             <a:r>
               <a:rPr lang="en-US" sz="1450" dirty="0">
                 <a:solidFill>
-                  <a:srgbClr val="2B2F4A"/>
+                  <a:srgbClr val="201D16"/>
                 </a:solidFill>
                 <a:latin typeface="Calibri" pitchFamily="34" charset="0"/>
                 <a:ea typeface="Calibri" pitchFamily="34" charset="-122"/>
@@ -3003,7 +2895,7 @@
       </p:sp>
       <p:sp>
         <p:nvSpPr>
-          <p:cNvPr id="15" name="Text 13"/>
+          <p:cNvPr id="15" name="Text 12"/>
           <p:cNvSpPr txBox="1"/>
           <p:nvPr/>
         </p:nvSpPr>
@@ -3028,7 +2920,7 @@
             <a:r>
               <a:rPr lang="en-US" sz="1000" dirty="0">
                 <a:solidFill>
-                  <a:srgbClr val="6B7099"/>
+                  <a:srgbClr val="8A7C6C"/>
                 </a:solidFill>
                 <a:latin typeface="Calibri" pitchFamily="34" charset="0"/>
                 <a:ea typeface="Calibri" pitchFamily="34" charset="-122"/>
@@ -3054,7 +2946,7 @@
     <p:bg>
       <p:bgPr>
         <a:solidFill>
-          <a:srgbClr val="EDEBF8"/>
+          <a:srgbClr val="F2EAD6"/>
         </a:solidFill>
       </p:bgPr>
     </p:bg>
@@ -3087,34 +2979,38 @@
             <a:avLst/>
           </a:prstGeom>
           <a:solidFill>
-            <a:srgbClr val="C89B3C"/>
+            <a:srgbClr val="E7ECE5"/>
           </a:solidFill>
           <a:ln/>
         </p:spPr>
       </p:sp>
-      <p:sp>
-        <p:nvSpPr>
-          <p:cNvPr id="3" name="Shape 1"/>
-          <p:cNvSpPr/>
-          <p:nvPr/>
-        </p:nvSpPr>
-        <p:spPr>
-          <a:xfrm>
-            <a:off x="672084" y="672084"/>
-            <a:ext cx="210312" cy="210312"/>
-          </a:xfrm>
-          <a:prstGeom prst="star5">
-            <a:avLst/>
-          </a:prstGeom>
-          <a:solidFill>
-            <a:srgbClr val="141A35"/>
-          </a:solidFill>
-          <a:ln/>
-        </p:spPr>
-      </p:sp>
-      <p:sp>
-        <p:nvSpPr>
-          <p:cNvPr id="4" name="Text 2"/>
+      <p:pic>
+        <p:nvPicPr>
+          <p:cNvPr id="3" name="Image 0" descr="mark-onlight.png">    </p:cNvPr>
+          <p:cNvPicPr>
+            <a:picLocks noChangeAspect="1"/>
+          </p:cNvPicPr>
+          <p:nvPr/>
+        </p:nvPicPr>
+        <p:blipFill>
+          <a:blip r:embed="rId1"/>
+          <a:stretch>
+            <a:fillRect/>
+          </a:stretch>
+        </p:blipFill>
+        <p:spPr>
+          <a:xfrm>
+            <a:off x="649224" y="649224"/>
+            <a:ext cx="256032" cy="256032"/>
+          </a:xfrm>
+          <a:prstGeom prst="rect">
+            <a:avLst/>
+          </a:prstGeom>
+        </p:spPr>
+      </p:pic>
+      <p:sp>
+        <p:nvSpPr>
+          <p:cNvPr id="4" name="Text 1"/>
           <p:cNvSpPr txBox="1"/>
           <p:nvPr/>
         </p:nvSpPr>
@@ -3139,7 +3035,7 @@
             <a:r>
               <a:rPr lang="en-US" sz="1200" b="1" spc="200" kern="0" dirty="0">
                 <a:solidFill>
-                  <a:srgbClr val="C89B3C"/>
+                  <a:srgbClr val="A8452A"/>
                 </a:solidFill>
                 <a:latin typeface="Calibri" pitchFamily="34" charset="0"/>
                 <a:ea typeface="Calibri" pitchFamily="34" charset="-122"/>
@@ -3153,7 +3049,7 @@
       </p:sp>
       <p:sp>
         <p:nvSpPr>
-          <p:cNvPr id="5" name="Text 3"/>
+          <p:cNvPr id="5" name="Text 2"/>
           <p:cNvSpPr txBox="1"/>
           <p:nvPr/>
         </p:nvSpPr>
@@ -3178,7 +3074,7 @@
             <a:r>
               <a:rPr lang="en-US" sz="2800" b="1" dirty="0">
                 <a:solidFill>
-                  <a:srgbClr val="141A35"/>
+                  <a:srgbClr val="253B2C"/>
                 </a:solidFill>
                 <a:latin typeface="Cambria" pitchFamily="34" charset="0"/>
                 <a:ea typeface="Cambria" pitchFamily="34" charset="-122"/>
@@ -3192,7 +3088,7 @@
       </p:sp>
       <p:sp>
         <p:nvSpPr>
-          <p:cNvPr id="6" name="Shape 4"/>
+          <p:cNvPr id="6" name="Shape 3"/>
           <p:cNvSpPr/>
           <p:nvPr/>
         </p:nvSpPr>
@@ -3203,15 +3099,15 @@
           </a:xfrm>
           <a:prstGeom prst="roundRect">
             <a:avLst>
-              <a:gd name="adj" fmla="val 5000"/>
+              <a:gd name="adj" fmla="val 3000"/>
             </a:avLst>
           </a:prstGeom>
           <a:solidFill>
-            <a:srgbClr val="F7F6FC"/>
+            <a:srgbClr val="FFFDF8"/>
           </a:solidFill>
           <a:ln w="12700">
             <a:solidFill>
-              <a:srgbClr val="DAD6EE"/>
+              <a:srgbClr val="DCD0B4"/>
             </a:solidFill>
             <a:prstDash val="solid"/>
           </a:ln>
@@ -3219,7 +3115,7 @@
       </p:sp>
       <p:sp>
         <p:nvSpPr>
-          <p:cNvPr id="7" name="Text 5"/>
+          <p:cNvPr id="7" name="Text 4"/>
           <p:cNvSpPr txBox="1"/>
           <p:nvPr/>
         </p:nvSpPr>
@@ -3244,7 +3140,7 @@
             <a:r>
               <a:rPr lang="en-US" sz="3200" b="1" dirty="0">
                 <a:solidFill>
-                  <a:srgbClr val="141A35"/>
+                  <a:srgbClr val="253B2C"/>
                 </a:solidFill>
                 <a:latin typeface="Cambria" pitchFamily="34" charset="0"/>
                 <a:ea typeface="Cambria" pitchFamily="34" charset="-122"/>
@@ -3258,7 +3154,7 @@
       </p:sp>
       <p:sp>
         <p:nvSpPr>
-          <p:cNvPr id="8" name="Text 6"/>
+          <p:cNvPr id="8" name="Text 5"/>
           <p:cNvSpPr txBox="1"/>
           <p:nvPr/>
         </p:nvSpPr>
@@ -3286,7 +3182,7 @@
             <a:r>
               <a:rPr lang="en-US" sz="1250" dirty="0">
                 <a:solidFill>
-                  <a:srgbClr val="6B7099"/>
+                  <a:srgbClr val="6B6354"/>
                 </a:solidFill>
                 <a:latin typeface="Calibri" pitchFamily="34" charset="0"/>
                 <a:ea typeface="Calibri" pitchFamily="34" charset="-122"/>
@@ -3306,7 +3202,7 @@
             <a:r>
               <a:rPr lang="en-US" sz="1250" dirty="0">
                 <a:solidFill>
-                  <a:srgbClr val="6B7099"/>
+                  <a:srgbClr val="6B6354"/>
                 </a:solidFill>
                 <a:latin typeface="Calibri" pitchFamily="34" charset="0"/>
                 <a:ea typeface="Calibri" pitchFamily="34" charset="-122"/>
@@ -3320,7 +3216,7 @@
       </p:sp>
       <p:sp>
         <p:nvSpPr>
-          <p:cNvPr id="9" name="Shape 7"/>
+          <p:cNvPr id="9" name="Shape 6"/>
           <p:cNvSpPr/>
           <p:nvPr/>
         </p:nvSpPr>
@@ -3331,15 +3227,15 @@
           </a:xfrm>
           <a:prstGeom prst="roundRect">
             <a:avLst>
-              <a:gd name="adj" fmla="val 5000"/>
+              <a:gd name="adj" fmla="val 3000"/>
             </a:avLst>
           </a:prstGeom>
           <a:solidFill>
-            <a:srgbClr val="F7F6FC"/>
+            <a:srgbClr val="FFFDF8"/>
           </a:solidFill>
           <a:ln w="12700">
             <a:solidFill>
-              <a:srgbClr val="DAD6EE"/>
+              <a:srgbClr val="DCD0B4"/>
             </a:solidFill>
             <a:prstDash val="solid"/>
           </a:ln>
@@ -3347,7 +3243,7 @@
       </p:sp>
       <p:sp>
         <p:nvSpPr>
-          <p:cNvPr id="10" name="Text 8"/>
+          <p:cNvPr id="10" name="Text 7"/>
           <p:cNvSpPr txBox="1"/>
           <p:nvPr/>
         </p:nvSpPr>
@@ -3372,7 +3268,7 @@
             <a:r>
               <a:rPr lang="en-US" sz="3200" b="1" dirty="0">
                 <a:solidFill>
-                  <a:srgbClr val="141A35"/>
+                  <a:srgbClr val="253B2C"/>
                 </a:solidFill>
                 <a:latin typeface="Cambria" pitchFamily="34" charset="0"/>
                 <a:ea typeface="Cambria" pitchFamily="34" charset="-122"/>
@@ -3386,7 +3282,7 @@
       </p:sp>
       <p:sp>
         <p:nvSpPr>
-          <p:cNvPr id="11" name="Text 9"/>
+          <p:cNvPr id="11" name="Text 8"/>
           <p:cNvSpPr txBox="1"/>
           <p:nvPr/>
         </p:nvSpPr>
@@ -3414,7 +3310,7 @@
             <a:r>
               <a:rPr lang="en-US" sz="1250" dirty="0">
                 <a:solidFill>
-                  <a:srgbClr val="6B7099"/>
+                  <a:srgbClr val="6B6354"/>
                 </a:solidFill>
                 <a:latin typeface="Calibri" pitchFamily="34" charset="0"/>
                 <a:ea typeface="Calibri" pitchFamily="34" charset="-122"/>
@@ -3434,7 +3330,7 @@
             <a:r>
               <a:rPr lang="en-US" sz="1250" dirty="0">
                 <a:solidFill>
-                  <a:srgbClr val="6B7099"/>
+                  <a:srgbClr val="6B6354"/>
                 </a:solidFill>
                 <a:latin typeface="Calibri" pitchFamily="34" charset="0"/>
                 <a:ea typeface="Calibri" pitchFamily="34" charset="-122"/>
@@ -3448,7 +3344,7 @@
       </p:sp>
       <p:sp>
         <p:nvSpPr>
-          <p:cNvPr id="12" name="Shape 10"/>
+          <p:cNvPr id="12" name="Shape 9"/>
           <p:cNvSpPr/>
           <p:nvPr/>
         </p:nvSpPr>
@@ -3459,15 +3355,15 @@
           </a:xfrm>
           <a:prstGeom prst="roundRect">
             <a:avLst>
-              <a:gd name="adj" fmla="val 5000"/>
+              <a:gd name="adj" fmla="val 3000"/>
             </a:avLst>
           </a:prstGeom>
           <a:solidFill>
-            <a:srgbClr val="F7F6FC"/>
+            <a:srgbClr val="FFFDF8"/>
           </a:solidFill>
           <a:ln w="12700">
             <a:solidFill>
-              <a:srgbClr val="DAD6EE"/>
+              <a:srgbClr val="DCD0B4"/>
             </a:solidFill>
             <a:prstDash val="solid"/>
           </a:ln>
@@ -3475,7 +3371,7 @@
       </p:sp>
       <p:sp>
         <p:nvSpPr>
-          <p:cNvPr id="13" name="Text 11"/>
+          <p:cNvPr id="13" name="Text 10"/>
           <p:cNvSpPr txBox="1"/>
           <p:nvPr/>
         </p:nvSpPr>
@@ -3500,7 +3396,7 @@
             <a:r>
               <a:rPr lang="en-US" sz="3200" b="1" dirty="0">
                 <a:solidFill>
-                  <a:srgbClr val="141A35"/>
+                  <a:srgbClr val="253B2C"/>
                 </a:solidFill>
                 <a:latin typeface="Cambria" pitchFamily="34" charset="0"/>
                 <a:ea typeface="Cambria" pitchFamily="34" charset="-122"/>
@@ -3514,7 +3410,7 @@
       </p:sp>
       <p:sp>
         <p:nvSpPr>
-          <p:cNvPr id="14" name="Text 12"/>
+          <p:cNvPr id="14" name="Text 11"/>
           <p:cNvSpPr txBox="1"/>
           <p:nvPr/>
         </p:nvSpPr>
@@ -3542,7 +3438,7 @@
             <a:r>
               <a:rPr lang="en-US" sz="1250" dirty="0">
                 <a:solidFill>
-                  <a:srgbClr val="6B7099"/>
+                  <a:srgbClr val="6B6354"/>
                 </a:solidFill>
                 <a:latin typeface="Calibri" pitchFamily="34" charset="0"/>
                 <a:ea typeface="Calibri" pitchFamily="34" charset="-122"/>
@@ -3562,7 +3458,7 @@
             <a:r>
               <a:rPr lang="en-US" sz="1250" dirty="0">
                 <a:solidFill>
-                  <a:srgbClr val="6B7099"/>
+                  <a:srgbClr val="6B6354"/>
                 </a:solidFill>
                 <a:latin typeface="Calibri" pitchFamily="34" charset="0"/>
                 <a:ea typeface="Calibri" pitchFamily="34" charset="-122"/>
@@ -3576,7 +3472,7 @@
       </p:sp>
       <p:sp>
         <p:nvSpPr>
-          <p:cNvPr id="15" name="Shape 13"/>
+          <p:cNvPr id="15" name="Shape 12"/>
           <p:cNvSpPr/>
           <p:nvPr/>
         </p:nvSpPr>
@@ -3587,15 +3483,15 @@
           </a:xfrm>
           <a:prstGeom prst="roundRect">
             <a:avLst>
-              <a:gd name="adj" fmla="val 5000"/>
+              <a:gd name="adj" fmla="val 3000"/>
             </a:avLst>
           </a:prstGeom>
           <a:solidFill>
-            <a:srgbClr val="F7F6FC"/>
+            <a:srgbClr val="FFFDF8"/>
           </a:solidFill>
           <a:ln w="12700">
             <a:solidFill>
-              <a:srgbClr val="DAD6EE"/>
+              <a:srgbClr val="DCD0B4"/>
             </a:solidFill>
             <a:prstDash val="solid"/>
           </a:ln>
@@ -3603,7 +3499,7 @@
       </p:sp>
       <p:sp>
         <p:nvSpPr>
-          <p:cNvPr id="16" name="Text 14"/>
+          <p:cNvPr id="16" name="Text 13"/>
           <p:cNvSpPr txBox="1"/>
           <p:nvPr/>
         </p:nvSpPr>
@@ -3628,7 +3524,7 @@
             <a:r>
               <a:rPr lang="en-US" sz="3200" b="1" dirty="0">
                 <a:solidFill>
-                  <a:srgbClr val="141A35"/>
+                  <a:srgbClr val="253B2C"/>
                 </a:solidFill>
                 <a:latin typeface="Cambria" pitchFamily="34" charset="0"/>
                 <a:ea typeface="Cambria" pitchFamily="34" charset="-122"/>
@@ -3642,7 +3538,7 @@
       </p:sp>
       <p:sp>
         <p:nvSpPr>
-          <p:cNvPr id="17" name="Text 15"/>
+          <p:cNvPr id="17" name="Text 14"/>
           <p:cNvSpPr txBox="1"/>
           <p:nvPr/>
         </p:nvSpPr>
@@ -3670,7 +3566,7 @@
             <a:r>
               <a:rPr lang="en-US" sz="1250" dirty="0">
                 <a:solidFill>
-                  <a:srgbClr val="6B7099"/>
+                  <a:srgbClr val="6B6354"/>
                 </a:solidFill>
                 <a:latin typeface="Calibri" pitchFamily="34" charset="0"/>
                 <a:ea typeface="Calibri" pitchFamily="34" charset="-122"/>
@@ -3690,7 +3586,7 @@
             <a:r>
               <a:rPr lang="en-US" sz="1250" dirty="0">
                 <a:solidFill>
-                  <a:srgbClr val="6B7099"/>
+                  <a:srgbClr val="6B6354"/>
                 </a:solidFill>
                 <a:latin typeface="Calibri" pitchFamily="34" charset="0"/>
                 <a:ea typeface="Calibri" pitchFamily="34" charset="-122"/>
@@ -3704,7 +3600,7 @@
       </p:sp>
       <p:sp>
         <p:nvSpPr>
-          <p:cNvPr id="18" name="Text 16"/>
+          <p:cNvPr id="18" name="Text 15"/>
           <p:cNvSpPr txBox="1"/>
           <p:nvPr/>
         </p:nvSpPr>
@@ -3729,7 +3625,7 @@
             <a:r>
               <a:rPr lang="en-US" sz="1250" i="1" dirty="0">
                 <a:solidFill>
-                  <a:srgbClr val="6B7099"/>
+                  <a:srgbClr val="6B6354"/>
                 </a:solidFill>
                 <a:latin typeface="Calibri" pitchFamily="34" charset="0"/>
                 <a:ea typeface="Calibri" pitchFamily="34" charset="-122"/>
@@ -3743,7 +3639,7 @@
       </p:sp>
       <p:sp>
         <p:nvSpPr>
-          <p:cNvPr id="19" name="Text 17"/>
+          <p:cNvPr id="19" name="Text 16"/>
           <p:cNvSpPr txBox="1"/>
           <p:nvPr/>
         </p:nvSpPr>
@@ -3768,7 +3664,7 @@
             <a:r>
               <a:rPr lang="en-US" sz="1000" dirty="0">
                 <a:solidFill>
-                  <a:srgbClr val="6B7099"/>
+                  <a:srgbClr val="8A7C6C"/>
                 </a:solidFill>
                 <a:latin typeface="Calibri" pitchFamily="34" charset="0"/>
                 <a:ea typeface="Calibri" pitchFamily="34" charset="-122"/>
@@ -3794,7 +3690,7 @@
     <p:bg>
       <p:bgPr>
         <a:solidFill>
-          <a:srgbClr val="EDEBF8"/>
+          <a:srgbClr val="F2EAD6"/>
         </a:solidFill>
       </p:bgPr>
     </p:bg>
@@ -3827,34 +3723,38 @@
             <a:avLst/>
           </a:prstGeom>
           <a:solidFill>
-            <a:srgbClr val="C89B3C"/>
+            <a:srgbClr val="E7ECE5"/>
           </a:solidFill>
           <a:ln/>
         </p:spPr>
       </p:sp>
-      <p:sp>
-        <p:nvSpPr>
-          <p:cNvPr id="3" name="Shape 1"/>
-          <p:cNvSpPr/>
-          <p:nvPr/>
-        </p:nvSpPr>
-        <p:spPr>
-          <a:xfrm>
-            <a:off x="672084" y="672084"/>
-            <a:ext cx="210312" cy="210312"/>
-          </a:xfrm>
-          <a:prstGeom prst="star5">
-            <a:avLst/>
-          </a:prstGeom>
-          <a:solidFill>
-            <a:srgbClr val="141A35"/>
-          </a:solidFill>
-          <a:ln/>
-        </p:spPr>
-      </p:sp>
-      <p:sp>
-        <p:nvSpPr>
-          <p:cNvPr id="4" name="Text 2"/>
+      <p:pic>
+        <p:nvPicPr>
+          <p:cNvPr id="3" name="Image 0" descr="mark-onlight.png">    </p:cNvPr>
+          <p:cNvPicPr>
+            <a:picLocks noChangeAspect="1"/>
+          </p:cNvPicPr>
+          <p:nvPr/>
+        </p:nvPicPr>
+        <p:blipFill>
+          <a:blip r:embed="rId1"/>
+          <a:stretch>
+            <a:fillRect/>
+          </a:stretch>
+        </p:blipFill>
+        <p:spPr>
+          <a:xfrm>
+            <a:off x="649224" y="649224"/>
+            <a:ext cx="256032" cy="256032"/>
+          </a:xfrm>
+          <a:prstGeom prst="rect">
+            <a:avLst/>
+          </a:prstGeom>
+        </p:spPr>
+      </p:pic>
+      <p:sp>
+        <p:nvSpPr>
+          <p:cNvPr id="4" name="Text 1"/>
           <p:cNvSpPr txBox="1"/>
           <p:nvPr/>
         </p:nvSpPr>
@@ -3879,7 +3779,7 @@
             <a:r>
               <a:rPr lang="en-US" sz="1200" b="1" spc="200" kern="0" dirty="0">
                 <a:solidFill>
-                  <a:srgbClr val="C89B3C"/>
+                  <a:srgbClr val="A8452A"/>
                 </a:solidFill>
                 <a:latin typeface="Calibri" pitchFamily="34" charset="0"/>
                 <a:ea typeface="Calibri" pitchFamily="34" charset="-122"/>
@@ -3893,7 +3793,7 @@
       </p:sp>
       <p:sp>
         <p:nvSpPr>
-          <p:cNvPr id="5" name="Text 3"/>
+          <p:cNvPr id="5" name="Text 2"/>
           <p:cNvSpPr txBox="1"/>
           <p:nvPr/>
         </p:nvSpPr>
@@ -3921,7 +3821,7 @@
             <a:r>
               <a:rPr lang="en-US" sz="2800" b="1" dirty="0">
                 <a:solidFill>
-                  <a:srgbClr val="141A35"/>
+                  <a:srgbClr val="253B2C"/>
                 </a:solidFill>
                 <a:latin typeface="Cambria" pitchFamily="34" charset="0"/>
                 <a:ea typeface="Cambria" pitchFamily="34" charset="-122"/>
@@ -3941,7 +3841,7 @@
             <a:r>
               <a:rPr lang="en-US" sz="2800" b="1" dirty="0">
                 <a:solidFill>
-                  <a:srgbClr val="141A35"/>
+                  <a:srgbClr val="253B2C"/>
                 </a:solidFill>
                 <a:latin typeface="Cambria" pitchFamily="34" charset="0"/>
                 <a:ea typeface="Cambria" pitchFamily="34" charset="-122"/>
@@ -3961,7 +3861,7 @@
             <a:r>
               <a:rPr lang="en-US" sz="2800" b="1" dirty="0">
                 <a:solidFill>
-                  <a:srgbClr val="141A35"/>
+                  <a:srgbClr val="253B2C"/>
                 </a:solidFill>
                 <a:latin typeface="Cambria" pitchFamily="34" charset="0"/>
                 <a:ea typeface="Cambria" pitchFamily="34" charset="-122"/>
@@ -3975,7 +3875,7 @@
       </p:sp>
       <p:sp>
         <p:nvSpPr>
-          <p:cNvPr id="6" name="Text 4"/>
+          <p:cNvPr id="6" name="Text 3"/>
           <p:cNvSpPr txBox="1"/>
           <p:nvPr/>
         </p:nvSpPr>
@@ -4003,7 +3903,7 @@
             <a:r>
               <a:rPr lang="en-US" sz="1450" dirty="0">
                 <a:solidFill>
-                  <a:srgbClr val="2B2F4A"/>
+                  <a:srgbClr val="201D16"/>
                 </a:solidFill>
                 <a:latin typeface="Calibri" pitchFamily="34" charset="0"/>
                 <a:ea typeface="Calibri" pitchFamily="34" charset="-122"/>
@@ -4023,7 +3923,7 @@
             <a:r>
               <a:rPr lang="en-US" sz="1450" dirty="0">
                 <a:solidFill>
-                  <a:srgbClr val="2B2F4A"/>
+                  <a:srgbClr val="201D16"/>
                 </a:solidFill>
                 <a:latin typeface="Calibri" pitchFamily="34" charset="0"/>
                 <a:ea typeface="Calibri" pitchFamily="34" charset="-122"/>
@@ -4043,7 +3943,7 @@
             <a:r>
               <a:rPr lang="en-US" sz="1450" dirty="0">
                 <a:solidFill>
-                  <a:srgbClr val="2B2F4A"/>
+                  <a:srgbClr val="201D16"/>
                 </a:solidFill>
                 <a:latin typeface="Calibri" pitchFamily="34" charset="0"/>
                 <a:ea typeface="Calibri" pitchFamily="34" charset="-122"/>
@@ -4057,7 +3957,7 @@
       </p:sp>
       <p:sp>
         <p:nvSpPr>
-          <p:cNvPr id="7" name="Shape 5"/>
+          <p:cNvPr id="7" name="Shape 4"/>
           <p:cNvSpPr/>
           <p:nvPr/>
         </p:nvSpPr>
@@ -4068,18 +3968,18 @@
           </a:xfrm>
           <a:prstGeom prst="roundRect">
             <a:avLst>
-              <a:gd name="adj" fmla="val 5263"/>
+              <a:gd name="adj" fmla="val 3158"/>
             </a:avLst>
           </a:prstGeom>
           <a:solidFill>
-            <a:srgbClr val="141A35"/>
+            <a:srgbClr val="14201A"/>
           </a:solidFill>
           <a:ln/>
         </p:spPr>
       </p:sp>
       <p:sp>
         <p:nvSpPr>
-          <p:cNvPr id="8" name="Text 6"/>
+          <p:cNvPr id="8" name="Text 5"/>
           <p:cNvSpPr txBox="1"/>
           <p:nvPr/>
         </p:nvSpPr>
@@ -4104,7 +4004,7 @@
             <a:r>
               <a:rPr lang="en-US" sz="4000" b="1" dirty="0">
                 <a:solidFill>
-                  <a:srgbClr val="C89B3C"/>
+                  <a:srgbClr val="C25F3D"/>
                 </a:solidFill>
                 <a:latin typeface="Cambria" pitchFamily="34" charset="0"/>
                 <a:ea typeface="Cambria" pitchFamily="34" charset="-122"/>
@@ -4118,7 +4018,7 @@
       </p:sp>
       <p:sp>
         <p:nvSpPr>
-          <p:cNvPr id="9" name="Text 7"/>
+          <p:cNvPr id="9" name="Text 6"/>
           <p:cNvSpPr txBox="1"/>
           <p:nvPr/>
         </p:nvSpPr>
@@ -4146,7 +4046,7 @@
             <a:r>
               <a:rPr lang="en-US" sz="1000" b="1" spc="100" kern="0" dirty="0">
                 <a:solidFill>
-                  <a:srgbClr val="E9E7F5"/>
+                  <a:srgbClr val="D8CFB8"/>
                 </a:solidFill>
                 <a:latin typeface="Calibri" pitchFamily="34" charset="0"/>
                 <a:ea typeface="Calibri" pitchFamily="34" charset="-122"/>
@@ -4166,7 +4066,7 @@
             <a:r>
               <a:rPr lang="en-US" sz="1000" b="1" spc="100" kern="0" dirty="0">
                 <a:solidFill>
-                  <a:srgbClr val="E9E7F5"/>
+                  <a:srgbClr val="D8CFB8"/>
                 </a:solidFill>
                 <a:latin typeface="Calibri" pitchFamily="34" charset="0"/>
                 <a:ea typeface="Calibri" pitchFamily="34" charset="-122"/>
@@ -4180,7 +4080,7 @@
       </p:sp>
       <p:sp>
         <p:nvSpPr>
-          <p:cNvPr id="10" name="Shape 8"/>
+          <p:cNvPr id="10" name="Shape 7"/>
           <p:cNvSpPr/>
           <p:nvPr/>
         </p:nvSpPr>
@@ -4195,7 +4095,7 @@
           <a:noFill/>
           <a:ln w="12700">
             <a:solidFill>
-              <a:srgbClr val="3A4079"/>
+              <a:srgbClr val="3E4C3D"/>
             </a:solidFill>
             <a:prstDash val="solid"/>
           </a:ln>
@@ -4203,7 +4103,7 @@
       </p:sp>
       <p:sp>
         <p:nvSpPr>
-          <p:cNvPr id="11" name="Text 9"/>
+          <p:cNvPr id="11" name="Text 8"/>
           <p:cNvSpPr txBox="1"/>
           <p:nvPr/>
         </p:nvSpPr>
@@ -4228,7 +4128,7 @@
             <a:r>
               <a:rPr lang="en-US" sz="4000" b="1" dirty="0">
                 <a:solidFill>
-                  <a:srgbClr val="C89B3C"/>
+                  <a:srgbClr val="C25F3D"/>
                 </a:solidFill>
                 <a:latin typeface="Cambria" pitchFamily="34" charset="0"/>
                 <a:ea typeface="Cambria" pitchFamily="34" charset="-122"/>
@@ -4242,7 +4142,7 @@
       </p:sp>
       <p:sp>
         <p:nvSpPr>
-          <p:cNvPr id="12" name="Text 10"/>
+          <p:cNvPr id="12" name="Text 9"/>
           <p:cNvSpPr txBox="1"/>
           <p:nvPr/>
         </p:nvSpPr>
@@ -4270,7 +4170,7 @@
             <a:r>
               <a:rPr lang="en-US" sz="1000" b="1" spc="50" kern="0" dirty="0">
                 <a:solidFill>
-                  <a:srgbClr val="E9E7F5"/>
+                  <a:srgbClr val="D8CFB8"/>
                 </a:solidFill>
                 <a:latin typeface="Calibri" pitchFamily="34" charset="0"/>
                 <a:ea typeface="Calibri" pitchFamily="34" charset="-122"/>
@@ -4290,7 +4190,7 @@
             <a:r>
               <a:rPr lang="en-US" sz="1000" b="1" spc="50" kern="0" dirty="0">
                 <a:solidFill>
-                  <a:srgbClr val="E9E7F5"/>
+                  <a:srgbClr val="D8CFB8"/>
                 </a:solidFill>
                 <a:latin typeface="Calibri" pitchFamily="34" charset="0"/>
                 <a:ea typeface="Calibri" pitchFamily="34" charset="-122"/>
@@ -4304,7 +4204,7 @@
       </p:sp>
       <p:sp>
         <p:nvSpPr>
-          <p:cNvPr id="13" name="Shape 11"/>
+          <p:cNvPr id="13" name="Shape 10"/>
           <p:cNvSpPr/>
           <p:nvPr/>
         </p:nvSpPr>
@@ -4319,7 +4219,7 @@
           <a:noFill/>
           <a:ln w="12700">
             <a:solidFill>
-              <a:srgbClr val="3A4079"/>
+              <a:srgbClr val="3E4C3D"/>
             </a:solidFill>
             <a:prstDash val="solid"/>
           </a:ln>
@@ -4327,7 +4227,7 @@
       </p:sp>
       <p:sp>
         <p:nvSpPr>
-          <p:cNvPr id="14" name="Text 12"/>
+          <p:cNvPr id="14" name="Text 11"/>
           <p:cNvSpPr txBox="1"/>
           <p:nvPr/>
         </p:nvSpPr>
@@ -4352,7 +4252,7 @@
             <a:r>
               <a:rPr lang="en-US" sz="3800" b="1" dirty="0">
                 <a:solidFill>
-                  <a:srgbClr val="C89B3C"/>
+                  <a:srgbClr val="C25F3D"/>
                 </a:solidFill>
                 <a:latin typeface="Cambria" pitchFamily="34" charset="0"/>
                 <a:ea typeface="Cambria" pitchFamily="34" charset="-122"/>
@@ -4366,7 +4266,7 @@
       </p:sp>
       <p:sp>
         <p:nvSpPr>
-          <p:cNvPr id="15" name="Text 13"/>
+          <p:cNvPr id="15" name="Text 12"/>
           <p:cNvSpPr txBox="1"/>
           <p:nvPr/>
         </p:nvSpPr>
@@ -4394,7 +4294,7 @@
             <a:r>
               <a:rPr lang="en-US" sz="1000" b="1" spc="50" kern="0" dirty="0">
                 <a:solidFill>
-                  <a:srgbClr val="E9E7F5"/>
+                  <a:srgbClr val="D8CFB8"/>
                 </a:solidFill>
                 <a:latin typeface="Calibri" pitchFamily="34" charset="0"/>
                 <a:ea typeface="Calibri" pitchFamily="34" charset="-122"/>
@@ -4414,7 +4314,7 @@
             <a:r>
               <a:rPr lang="en-US" sz="1000" b="1" spc="50" kern="0" dirty="0">
                 <a:solidFill>
-                  <a:srgbClr val="E9E7F5"/>
+                  <a:srgbClr val="D8CFB8"/>
                 </a:solidFill>
                 <a:latin typeface="Calibri" pitchFamily="34" charset="0"/>
                 <a:ea typeface="Calibri" pitchFamily="34" charset="-122"/>
@@ -4428,7 +4328,7 @@
       </p:sp>
       <p:sp>
         <p:nvSpPr>
-          <p:cNvPr id="16" name="Text 14"/>
+          <p:cNvPr id="16" name="Text 13"/>
           <p:cNvSpPr txBox="1"/>
           <p:nvPr/>
         </p:nvSpPr>
@@ -4456,7 +4356,7 @@
             <a:r>
               <a:rPr lang="en-US" sz="1450" dirty="0">
                 <a:solidFill>
-                  <a:srgbClr val="2B2F4A"/>
+                  <a:srgbClr val="201D16"/>
                 </a:solidFill>
                 <a:latin typeface="Calibri" pitchFamily="34" charset="0"/>
                 <a:ea typeface="Calibri" pitchFamily="34" charset="-122"/>
@@ -4476,7 +4376,7 @@
             <a:r>
               <a:rPr lang="en-US" sz="1450" dirty="0">
                 <a:solidFill>
-                  <a:srgbClr val="2B2F4A"/>
+                  <a:srgbClr val="201D16"/>
                 </a:solidFill>
                 <a:latin typeface="Calibri" pitchFamily="34" charset="0"/>
                 <a:ea typeface="Calibri" pitchFamily="34" charset="-122"/>
@@ -4496,7 +4396,7 @@
             <a:r>
               <a:rPr lang="en-US" sz="1450" dirty="0">
                 <a:solidFill>
-                  <a:srgbClr val="2B2F4A"/>
+                  <a:srgbClr val="201D16"/>
                 </a:solidFill>
                 <a:latin typeface="Calibri" pitchFamily="34" charset="0"/>
                 <a:ea typeface="Calibri" pitchFamily="34" charset="-122"/>
@@ -4510,7 +4410,7 @@
       </p:sp>
       <p:sp>
         <p:nvSpPr>
-          <p:cNvPr id="17" name="Text 15"/>
+          <p:cNvPr id="17" name="Text 14"/>
           <p:cNvSpPr txBox="1"/>
           <p:nvPr/>
         </p:nvSpPr>
@@ -4535,7 +4435,7 @@
             <a:r>
               <a:rPr lang="en-US" sz="1000" dirty="0">
                 <a:solidFill>
-                  <a:srgbClr val="6B7099"/>
+                  <a:srgbClr val="8A7C6C"/>
                 </a:solidFill>
                 <a:latin typeface="Calibri" pitchFamily="34" charset="0"/>
                 <a:ea typeface="Calibri" pitchFamily="34" charset="-122"/>
@@ -4561,7 +4461,7 @@
     <p:bg>
       <p:bgPr>
         <a:solidFill>
-          <a:srgbClr val="EDEBF8"/>
+          <a:srgbClr val="F2EAD6"/>
         </a:solidFill>
       </p:bgPr>
     </p:bg>
@@ -4594,34 +4494,38 @@
             <a:avLst/>
           </a:prstGeom>
           <a:solidFill>
-            <a:srgbClr val="C89B3C"/>
+            <a:srgbClr val="E7ECE5"/>
           </a:solidFill>
           <a:ln/>
         </p:spPr>
       </p:sp>
-      <p:sp>
-        <p:nvSpPr>
-          <p:cNvPr id="3" name="Shape 1"/>
-          <p:cNvSpPr/>
-          <p:nvPr/>
-        </p:nvSpPr>
-        <p:spPr>
-          <a:xfrm>
-            <a:off x="672084" y="672084"/>
-            <a:ext cx="210312" cy="210312"/>
-          </a:xfrm>
-          <a:prstGeom prst="star5">
-            <a:avLst/>
-          </a:prstGeom>
-          <a:solidFill>
-            <a:srgbClr val="141A35"/>
-          </a:solidFill>
-          <a:ln/>
-        </p:spPr>
-      </p:sp>
-      <p:sp>
-        <p:nvSpPr>
-          <p:cNvPr id="4" name="Text 2"/>
+      <p:pic>
+        <p:nvPicPr>
+          <p:cNvPr id="3" name="Image 0" descr="mark-onlight.png">    </p:cNvPr>
+          <p:cNvPicPr>
+            <a:picLocks noChangeAspect="1"/>
+          </p:cNvPicPr>
+          <p:nvPr/>
+        </p:nvPicPr>
+        <p:blipFill>
+          <a:blip r:embed="rId1"/>
+          <a:stretch>
+            <a:fillRect/>
+          </a:stretch>
+        </p:blipFill>
+        <p:spPr>
+          <a:xfrm>
+            <a:off x="649224" y="649224"/>
+            <a:ext cx="256032" cy="256032"/>
+          </a:xfrm>
+          <a:prstGeom prst="rect">
+            <a:avLst/>
+          </a:prstGeom>
+        </p:spPr>
+      </p:pic>
+      <p:sp>
+        <p:nvSpPr>
+          <p:cNvPr id="4" name="Text 1"/>
           <p:cNvSpPr txBox="1"/>
           <p:nvPr/>
         </p:nvSpPr>
@@ -4646,7 +4550,7 @@
             <a:r>
               <a:rPr lang="en-US" sz="1200" b="1" spc="200" kern="0" dirty="0">
                 <a:solidFill>
-                  <a:srgbClr val="C89B3C"/>
+                  <a:srgbClr val="A8452A"/>
                 </a:solidFill>
                 <a:latin typeface="Calibri" pitchFamily="34" charset="0"/>
                 <a:ea typeface="Calibri" pitchFamily="34" charset="-122"/>
@@ -4660,7 +4564,7 @@
       </p:sp>
       <p:sp>
         <p:nvSpPr>
-          <p:cNvPr id="5" name="Text 3"/>
+          <p:cNvPr id="5" name="Text 2"/>
           <p:cNvSpPr txBox="1"/>
           <p:nvPr/>
         </p:nvSpPr>
@@ -4688,7 +4592,7 @@
             <a:r>
               <a:rPr lang="en-US" sz="2800" b="1" dirty="0">
                 <a:solidFill>
-                  <a:srgbClr val="141A35"/>
+                  <a:srgbClr val="253B2C"/>
                 </a:solidFill>
                 <a:latin typeface="Cambria" pitchFamily="34" charset="0"/>
                 <a:ea typeface="Cambria" pitchFamily="34" charset="-122"/>
@@ -4708,7 +4612,7 @@
             <a:r>
               <a:rPr lang="en-US" sz="2800" b="1" dirty="0">
                 <a:solidFill>
-                  <a:srgbClr val="141A35"/>
+                  <a:srgbClr val="253B2C"/>
                 </a:solidFill>
                 <a:latin typeface="Cambria" pitchFamily="34" charset="0"/>
                 <a:ea typeface="Cambria" pitchFamily="34" charset="-122"/>
@@ -4722,7 +4626,7 @@
       </p:sp>
       <p:sp>
         <p:nvSpPr>
-          <p:cNvPr id="6" name="Shape 4"/>
+          <p:cNvPr id="6" name="Shape 3"/>
           <p:cNvSpPr/>
           <p:nvPr/>
         </p:nvSpPr>
@@ -4733,15 +4637,15 @@
           </a:xfrm>
           <a:prstGeom prst="roundRect">
             <a:avLst>
-              <a:gd name="adj" fmla="val 5882"/>
+              <a:gd name="adj" fmla="val 3529"/>
             </a:avLst>
           </a:prstGeom>
           <a:solidFill>
-            <a:srgbClr val="F7F6FC"/>
+            <a:srgbClr val="FFFDF8"/>
           </a:solidFill>
           <a:ln w="12700">
             <a:solidFill>
-              <a:srgbClr val="DAD6EE"/>
+              <a:srgbClr val="DCD0B4"/>
             </a:solidFill>
             <a:prstDash val="solid"/>
           </a:ln>
@@ -4749,7 +4653,7 @@
       </p:sp>
       <p:sp>
         <p:nvSpPr>
-          <p:cNvPr id="7" name="Text 5"/>
+          <p:cNvPr id="7" name="Text 4"/>
           <p:cNvSpPr txBox="1"/>
           <p:nvPr/>
         </p:nvSpPr>
@@ -4774,7 +4678,7 @@
             <a:r>
               <a:rPr lang="en-US" sz="1100" b="1" spc="150" kern="0" dirty="0">
                 <a:solidFill>
-                  <a:srgbClr val="C89B3C"/>
+                  <a:srgbClr val="A8452A"/>
                 </a:solidFill>
                 <a:latin typeface="Calibri" pitchFamily="34" charset="0"/>
                 <a:ea typeface="Calibri" pitchFamily="34" charset="-122"/>
@@ -4788,7 +4692,7 @@
       </p:sp>
       <p:sp>
         <p:nvSpPr>
-          <p:cNvPr id="8" name="Text 6"/>
+          <p:cNvPr id="8" name="Text 5"/>
           <p:cNvSpPr txBox="1"/>
           <p:nvPr/>
         </p:nvSpPr>
@@ -4816,7 +4720,7 @@
             <a:r>
               <a:rPr lang="en-US" sz="1350" dirty="0">
                 <a:solidFill>
-                  <a:srgbClr val="2B2F4A"/>
+                  <a:srgbClr val="201D16"/>
                 </a:solidFill>
                 <a:latin typeface="Calibri" pitchFamily="34" charset="0"/>
                 <a:ea typeface="Calibri" pitchFamily="34" charset="-122"/>
@@ -4836,7 +4740,7 @@
             <a:r>
               <a:rPr lang="en-US" sz="1350" dirty="0">
                 <a:solidFill>
-                  <a:srgbClr val="2B2F4A"/>
+                  <a:srgbClr val="201D16"/>
                 </a:solidFill>
                 <a:latin typeface="Calibri" pitchFamily="34" charset="0"/>
                 <a:ea typeface="Calibri" pitchFamily="34" charset="-122"/>
@@ -4856,7 +4760,7 @@
             <a:r>
               <a:rPr lang="en-US" sz="1350" dirty="0">
                 <a:solidFill>
-                  <a:srgbClr val="2B2F4A"/>
+                  <a:srgbClr val="201D16"/>
                 </a:solidFill>
                 <a:latin typeface="Calibri" pitchFamily="34" charset="0"/>
                 <a:ea typeface="Calibri" pitchFamily="34" charset="-122"/>
@@ -4870,7 +4774,7 @@
       </p:sp>
       <p:sp>
         <p:nvSpPr>
-          <p:cNvPr id="9" name="Shape 7"/>
+          <p:cNvPr id="9" name="Shape 6"/>
           <p:cNvSpPr/>
           <p:nvPr/>
         </p:nvSpPr>
@@ -4881,18 +4785,18 @@
           </a:xfrm>
           <a:prstGeom prst="roundRect">
             <a:avLst>
-              <a:gd name="adj" fmla="val 5882"/>
+              <a:gd name="adj" fmla="val 3529"/>
             </a:avLst>
           </a:prstGeom>
           <a:solidFill>
-            <a:srgbClr val="141A35"/>
+            <a:srgbClr val="14201A"/>
           </a:solidFill>
           <a:ln/>
         </p:spPr>
       </p:sp>
       <p:sp>
         <p:nvSpPr>
-          <p:cNvPr id="10" name="Text 8"/>
+          <p:cNvPr id="10" name="Text 7"/>
           <p:cNvSpPr txBox="1"/>
           <p:nvPr/>
         </p:nvSpPr>
@@ -4917,7 +4821,7 @@
             <a:r>
               <a:rPr lang="en-US" sz="1100" b="1" spc="150" kern="0" dirty="0">
                 <a:solidFill>
-                  <a:srgbClr val="E6D6A8"/>
+                  <a:srgbClr val="C25F3D"/>
                 </a:solidFill>
                 <a:latin typeface="Calibri" pitchFamily="34" charset="0"/>
                 <a:ea typeface="Calibri" pitchFamily="34" charset="-122"/>
@@ -4931,7 +4835,7 @@
       </p:sp>
       <p:sp>
         <p:nvSpPr>
-          <p:cNvPr id="11" name="Text 9"/>
+          <p:cNvPr id="11" name="Text 8"/>
           <p:cNvSpPr txBox="1"/>
           <p:nvPr/>
         </p:nvSpPr>
@@ -4959,7 +4863,7 @@
             <a:r>
               <a:rPr lang="en-US" sz="1350" dirty="0">
                 <a:solidFill>
-                  <a:srgbClr val="E9E7F5"/>
+                  <a:srgbClr val="EDE6D4"/>
                 </a:solidFill>
                 <a:latin typeface="Calibri" pitchFamily="34" charset="0"/>
                 <a:ea typeface="Calibri" pitchFamily="34" charset="-122"/>
@@ -4979,7 +4883,7 @@
             <a:r>
               <a:rPr lang="en-US" sz="1350" dirty="0">
                 <a:solidFill>
-                  <a:srgbClr val="E9E7F5"/>
+                  <a:srgbClr val="EDE6D4"/>
                 </a:solidFill>
                 <a:latin typeface="Calibri" pitchFamily="34" charset="0"/>
                 <a:ea typeface="Calibri" pitchFamily="34" charset="-122"/>
@@ -4999,7 +4903,7 @@
             <a:r>
               <a:rPr lang="en-US" sz="1350" dirty="0">
                 <a:solidFill>
-                  <a:srgbClr val="E9E7F5"/>
+                  <a:srgbClr val="EDE6D4"/>
                 </a:solidFill>
                 <a:latin typeface="Calibri" pitchFamily="34" charset="0"/>
                 <a:ea typeface="Calibri" pitchFamily="34" charset="-122"/>
@@ -5013,7 +4917,7 @@
       </p:sp>
       <p:sp>
         <p:nvSpPr>
-          <p:cNvPr id="12" name="Text 10"/>
+          <p:cNvPr id="12" name="Text 9"/>
           <p:cNvSpPr txBox="1"/>
           <p:nvPr/>
         </p:nvSpPr>
@@ -5041,7 +4945,7 @@
             <a:r>
               <a:rPr lang="en-US" sz="1300" i="1" dirty="0">
                 <a:solidFill>
-                  <a:srgbClr val="6B7099"/>
+                  <a:srgbClr val="6B6354"/>
                 </a:solidFill>
                 <a:latin typeface="Calibri" pitchFamily="34" charset="0"/>
                 <a:ea typeface="Calibri" pitchFamily="34" charset="-122"/>
@@ -5061,7 +4965,7 @@
             <a:r>
               <a:rPr lang="en-US" sz="1300" i="1" dirty="0">
                 <a:solidFill>
-                  <a:srgbClr val="6B7099"/>
+                  <a:srgbClr val="6B6354"/>
                 </a:solidFill>
                 <a:latin typeface="Calibri" pitchFamily="34" charset="0"/>
                 <a:ea typeface="Calibri" pitchFamily="34" charset="-122"/>
@@ -5075,7 +4979,7 @@
       </p:sp>
       <p:sp>
         <p:nvSpPr>
-          <p:cNvPr id="13" name="Text 11"/>
+          <p:cNvPr id="13" name="Text 10"/>
           <p:cNvSpPr txBox="1"/>
           <p:nvPr/>
         </p:nvSpPr>
@@ -5100,7 +5004,7 @@
             <a:r>
               <a:rPr lang="en-US" sz="1000" dirty="0">
                 <a:solidFill>
-                  <a:srgbClr val="6B7099"/>
+                  <a:srgbClr val="8A7C6C"/>
                 </a:solidFill>
                 <a:latin typeface="Calibri" pitchFamily="34" charset="0"/>
                 <a:ea typeface="Calibri" pitchFamily="34" charset="-122"/>
@@ -5126,7 +5030,7 @@
     <p:bg>
       <p:bgPr>
         <a:solidFill>
-          <a:srgbClr val="EDEBF8"/>
+          <a:srgbClr val="F2EAD6"/>
         </a:solidFill>
       </p:bgPr>
     </p:bg>
@@ -5159,34 +5063,38 @@
             <a:avLst/>
           </a:prstGeom>
           <a:solidFill>
-            <a:srgbClr val="C89B3C"/>
+            <a:srgbClr val="E7ECE5"/>
           </a:solidFill>
           <a:ln/>
         </p:spPr>
       </p:sp>
-      <p:sp>
-        <p:nvSpPr>
-          <p:cNvPr id="3" name="Shape 1"/>
-          <p:cNvSpPr/>
-          <p:nvPr/>
-        </p:nvSpPr>
-        <p:spPr>
-          <a:xfrm>
-            <a:off x="672084" y="672084"/>
-            <a:ext cx="210312" cy="210312"/>
-          </a:xfrm>
-          <a:prstGeom prst="star5">
-            <a:avLst/>
-          </a:prstGeom>
-          <a:solidFill>
-            <a:srgbClr val="141A35"/>
-          </a:solidFill>
-          <a:ln/>
-        </p:spPr>
-      </p:sp>
-      <p:sp>
-        <p:nvSpPr>
-          <p:cNvPr id="4" name="Text 2"/>
+      <p:pic>
+        <p:nvPicPr>
+          <p:cNvPr id="3" name="Image 0" descr="mark-onlight.png">    </p:cNvPr>
+          <p:cNvPicPr>
+            <a:picLocks noChangeAspect="1"/>
+          </p:cNvPicPr>
+          <p:nvPr/>
+        </p:nvPicPr>
+        <p:blipFill>
+          <a:blip r:embed="rId1"/>
+          <a:stretch>
+            <a:fillRect/>
+          </a:stretch>
+        </p:blipFill>
+        <p:spPr>
+          <a:xfrm>
+            <a:off x="649224" y="649224"/>
+            <a:ext cx="256032" cy="256032"/>
+          </a:xfrm>
+          <a:prstGeom prst="rect">
+            <a:avLst/>
+          </a:prstGeom>
+        </p:spPr>
+      </p:pic>
+      <p:sp>
+        <p:nvSpPr>
+          <p:cNvPr id="4" name="Text 1"/>
           <p:cNvSpPr txBox="1"/>
           <p:nvPr/>
         </p:nvSpPr>
@@ -5211,7 +5119,7 @@
             <a:r>
               <a:rPr lang="en-US" sz="1200" b="1" spc="200" kern="0" dirty="0">
                 <a:solidFill>
-                  <a:srgbClr val="C89B3C"/>
+                  <a:srgbClr val="A8452A"/>
                 </a:solidFill>
                 <a:latin typeface="Calibri" pitchFamily="34" charset="0"/>
                 <a:ea typeface="Calibri" pitchFamily="34" charset="-122"/>
@@ -5225,7 +5133,7 @@
       </p:sp>
       <p:sp>
         <p:nvSpPr>
-          <p:cNvPr id="5" name="Text 3"/>
+          <p:cNvPr id="5" name="Text 2"/>
           <p:cNvSpPr txBox="1"/>
           <p:nvPr/>
         </p:nvSpPr>
@@ -5253,7 +5161,7 @@
             <a:r>
               <a:rPr lang="en-US" sz="2800" b="1" dirty="0">
                 <a:solidFill>
-                  <a:srgbClr val="141A35"/>
+                  <a:srgbClr val="253B2C"/>
                 </a:solidFill>
                 <a:latin typeface="Cambria" pitchFamily="34" charset="0"/>
                 <a:ea typeface="Cambria" pitchFamily="34" charset="-122"/>
@@ -5273,7 +5181,7 @@
             <a:r>
               <a:rPr lang="en-US" sz="2800" b="1" dirty="0">
                 <a:solidFill>
-                  <a:srgbClr val="141A35"/>
+                  <a:srgbClr val="253B2C"/>
                 </a:solidFill>
                 <a:latin typeface="Cambria" pitchFamily="34" charset="0"/>
                 <a:ea typeface="Cambria" pitchFamily="34" charset="-122"/>
@@ -5287,7 +5195,7 @@
       </p:sp>
       <p:sp>
         <p:nvSpPr>
-          <p:cNvPr id="6" name="Shape 4"/>
+          <p:cNvPr id="6" name="Shape 3"/>
           <p:cNvSpPr/>
           <p:nvPr/>
         </p:nvSpPr>
@@ -5300,14 +5208,14 @@
             <a:avLst/>
           </a:prstGeom>
           <a:solidFill>
-            <a:srgbClr val="C89B3C"/>
+            <a:srgbClr val="A8452A"/>
           </a:solidFill>
           <a:ln/>
         </p:spPr>
       </p:sp>
       <p:sp>
         <p:nvSpPr>
-          <p:cNvPr id="7" name="Text 5"/>
+          <p:cNvPr id="7" name="Text 4"/>
           <p:cNvSpPr txBox="1"/>
           <p:nvPr/>
         </p:nvSpPr>
@@ -5332,7 +5240,7 @@
             <a:r>
               <a:rPr lang="en-US" sz="1500" b="1" dirty="0">
                 <a:solidFill>
-                  <a:srgbClr val="141A35"/>
+                  <a:srgbClr val="253B2C"/>
                 </a:solidFill>
                 <a:latin typeface="Calibri" pitchFamily="34" charset="0"/>
                 <a:ea typeface="Calibri" pitchFamily="34" charset="-122"/>
@@ -5346,7 +5254,7 @@
       </p:sp>
       <p:sp>
         <p:nvSpPr>
-          <p:cNvPr id="8" name="Text 6"/>
+          <p:cNvPr id="8" name="Text 5"/>
           <p:cNvSpPr txBox="1"/>
           <p:nvPr/>
         </p:nvSpPr>
@@ -5374,7 +5282,7 @@
             <a:r>
               <a:rPr lang="en-US" sz="1300" dirty="0">
                 <a:solidFill>
-                  <a:srgbClr val="2B2F4A"/>
+                  <a:srgbClr val="201D16"/>
                 </a:solidFill>
                 <a:latin typeface="Calibri" pitchFamily="34" charset="0"/>
                 <a:ea typeface="Calibri" pitchFamily="34" charset="-122"/>
@@ -5388,7 +5296,7 @@
       </p:sp>
       <p:sp>
         <p:nvSpPr>
-          <p:cNvPr id="9" name="Shape 7"/>
+          <p:cNvPr id="9" name="Shape 6"/>
           <p:cNvSpPr/>
           <p:nvPr/>
         </p:nvSpPr>
@@ -5401,14 +5309,14 @@
             <a:avLst/>
           </a:prstGeom>
           <a:solidFill>
-            <a:srgbClr val="C89B3C"/>
+            <a:srgbClr val="A8452A"/>
           </a:solidFill>
           <a:ln/>
         </p:spPr>
       </p:sp>
       <p:sp>
         <p:nvSpPr>
-          <p:cNvPr id="10" name="Text 8"/>
+          <p:cNvPr id="10" name="Text 7"/>
           <p:cNvSpPr txBox="1"/>
           <p:nvPr/>
         </p:nvSpPr>
@@ -5433,7 +5341,7 @@
             <a:r>
               <a:rPr lang="en-US" sz="1500" b="1" dirty="0">
                 <a:solidFill>
-                  <a:srgbClr val="141A35"/>
+                  <a:srgbClr val="253B2C"/>
                 </a:solidFill>
                 <a:latin typeface="Calibri" pitchFamily="34" charset="0"/>
                 <a:ea typeface="Calibri" pitchFamily="34" charset="-122"/>
@@ -5447,7 +5355,7 @@
       </p:sp>
       <p:sp>
         <p:nvSpPr>
-          <p:cNvPr id="11" name="Text 9"/>
+          <p:cNvPr id="11" name="Text 8"/>
           <p:cNvSpPr txBox="1"/>
           <p:nvPr/>
         </p:nvSpPr>
@@ -5475,7 +5383,7 @@
             <a:r>
               <a:rPr lang="en-US" sz="1300" dirty="0">
                 <a:solidFill>
-                  <a:srgbClr val="2B2F4A"/>
+                  <a:srgbClr val="201D16"/>
                 </a:solidFill>
                 <a:latin typeface="Calibri" pitchFamily="34" charset="0"/>
                 <a:ea typeface="Calibri" pitchFamily="34" charset="-122"/>
@@ -5489,7 +5397,7 @@
       </p:sp>
       <p:sp>
         <p:nvSpPr>
-          <p:cNvPr id="12" name="Shape 10"/>
+          <p:cNvPr id="12" name="Shape 9"/>
           <p:cNvSpPr/>
           <p:nvPr/>
         </p:nvSpPr>
@@ -5502,14 +5410,14 @@
             <a:avLst/>
           </a:prstGeom>
           <a:solidFill>
-            <a:srgbClr val="C89B3C"/>
+            <a:srgbClr val="A8452A"/>
           </a:solidFill>
           <a:ln/>
         </p:spPr>
       </p:sp>
       <p:sp>
         <p:nvSpPr>
-          <p:cNvPr id="13" name="Text 11"/>
+          <p:cNvPr id="13" name="Text 10"/>
           <p:cNvSpPr txBox="1"/>
           <p:nvPr/>
         </p:nvSpPr>
@@ -5534,7 +5442,7 @@
             <a:r>
               <a:rPr lang="en-US" sz="1500" b="1" dirty="0">
                 <a:solidFill>
-                  <a:srgbClr val="141A35"/>
+                  <a:srgbClr val="253B2C"/>
                 </a:solidFill>
                 <a:latin typeface="Calibri" pitchFamily="34" charset="0"/>
                 <a:ea typeface="Calibri" pitchFamily="34" charset="-122"/>
@@ -5548,7 +5456,7 @@
       </p:sp>
       <p:sp>
         <p:nvSpPr>
-          <p:cNvPr id="14" name="Text 12"/>
+          <p:cNvPr id="14" name="Text 11"/>
           <p:cNvSpPr txBox="1"/>
           <p:nvPr/>
         </p:nvSpPr>
@@ -5576,7 +5484,7 @@
             <a:r>
               <a:rPr lang="en-US" sz="1300" dirty="0">
                 <a:solidFill>
-                  <a:srgbClr val="2B2F4A"/>
+                  <a:srgbClr val="201D16"/>
                 </a:solidFill>
                 <a:latin typeface="Calibri" pitchFamily="34" charset="0"/>
                 <a:ea typeface="Calibri" pitchFamily="34" charset="-122"/>
@@ -5590,7 +5498,7 @@
       </p:sp>
       <p:sp>
         <p:nvSpPr>
-          <p:cNvPr id="15" name="Shape 13"/>
+          <p:cNvPr id="15" name="Shape 12"/>
           <p:cNvSpPr/>
           <p:nvPr/>
         </p:nvSpPr>
@@ -5601,18 +5509,18 @@
           </a:xfrm>
           <a:prstGeom prst="roundRect">
             <a:avLst>
-              <a:gd name="adj" fmla="val 8696"/>
+              <a:gd name="adj" fmla="val 5217"/>
             </a:avLst>
           </a:prstGeom>
           <a:solidFill>
-            <a:srgbClr val="141A35"/>
+            <a:srgbClr val="14201A"/>
           </a:solidFill>
           <a:ln/>
         </p:spPr>
       </p:sp>
       <p:sp>
         <p:nvSpPr>
-          <p:cNvPr id="16" name="Text 14"/>
+          <p:cNvPr id="16" name="Text 13"/>
           <p:cNvSpPr txBox="1"/>
           <p:nvPr/>
         </p:nvSpPr>
@@ -5640,7 +5548,7 @@
             <a:r>
               <a:rPr lang="en-US" sz="1350" b="1" dirty="0">
                 <a:solidFill>
-                  <a:srgbClr val="FFFFFF"/>
+                  <a:srgbClr val="F2EAD6"/>
                 </a:solidFill>
                 <a:latin typeface="Calibri" pitchFamily="34" charset="0"/>
                 <a:ea typeface="Calibri" pitchFamily="34" charset="-122"/>
@@ -5660,7 +5568,7 @@
             <a:r>
               <a:rPr lang="en-US" sz="1350" b="1" dirty="0">
                 <a:solidFill>
-                  <a:srgbClr val="FFFFFF"/>
+                  <a:srgbClr val="F2EAD6"/>
                 </a:solidFill>
                 <a:latin typeface="Calibri" pitchFamily="34" charset="0"/>
                 <a:ea typeface="Calibri" pitchFamily="34" charset="-122"/>
@@ -5674,7 +5582,7 @@
       </p:sp>
       <p:sp>
         <p:nvSpPr>
-          <p:cNvPr id="17" name="Text 15"/>
+          <p:cNvPr id="17" name="Text 14"/>
           <p:cNvSpPr txBox="1"/>
           <p:nvPr/>
         </p:nvSpPr>
@@ -5699,7 +5607,7 @@
             <a:r>
               <a:rPr lang="en-US" sz="1000" dirty="0">
                 <a:solidFill>
-                  <a:srgbClr val="6B7099"/>
+                  <a:srgbClr val="8A7C6C"/>
                 </a:solidFill>
                 <a:latin typeface="Calibri" pitchFamily="34" charset="0"/>
                 <a:ea typeface="Calibri" pitchFamily="34" charset="-122"/>
@@ -5725,7 +5633,7 @@
     <p:bg>
       <p:bgPr>
         <a:solidFill>
-          <a:srgbClr val="EDEBF8"/>
+          <a:srgbClr val="F2EAD6"/>
         </a:solidFill>
       </p:bgPr>
     </p:bg>
@@ -5758,34 +5666,38 @@
             <a:avLst/>
           </a:prstGeom>
           <a:solidFill>
-            <a:srgbClr val="C89B3C"/>
+            <a:srgbClr val="E7ECE5"/>
           </a:solidFill>
           <a:ln/>
         </p:spPr>
       </p:sp>
-      <p:sp>
-        <p:nvSpPr>
-          <p:cNvPr id="3" name="Shape 1"/>
-          <p:cNvSpPr/>
-          <p:nvPr/>
-        </p:nvSpPr>
-        <p:spPr>
-          <a:xfrm>
-            <a:off x="672084" y="672084"/>
-            <a:ext cx="210312" cy="210312"/>
-          </a:xfrm>
-          <a:prstGeom prst="star5">
-            <a:avLst/>
-          </a:prstGeom>
-          <a:solidFill>
-            <a:srgbClr val="141A35"/>
-          </a:solidFill>
-          <a:ln/>
-        </p:spPr>
-      </p:sp>
-      <p:sp>
-        <p:nvSpPr>
-          <p:cNvPr id="4" name="Text 2"/>
+      <p:pic>
+        <p:nvPicPr>
+          <p:cNvPr id="3" name="Image 0" descr="mark-onlight.png">    </p:cNvPr>
+          <p:cNvPicPr>
+            <a:picLocks noChangeAspect="1"/>
+          </p:cNvPicPr>
+          <p:nvPr/>
+        </p:nvPicPr>
+        <p:blipFill>
+          <a:blip r:embed="rId1"/>
+          <a:stretch>
+            <a:fillRect/>
+          </a:stretch>
+        </p:blipFill>
+        <p:spPr>
+          <a:xfrm>
+            <a:off x="649224" y="649224"/>
+            <a:ext cx="256032" cy="256032"/>
+          </a:xfrm>
+          <a:prstGeom prst="rect">
+            <a:avLst/>
+          </a:prstGeom>
+        </p:spPr>
+      </p:pic>
+      <p:sp>
+        <p:nvSpPr>
+          <p:cNvPr id="4" name="Text 1"/>
           <p:cNvSpPr txBox="1"/>
           <p:nvPr/>
         </p:nvSpPr>
@@ -5810,7 +5722,7 @@
             <a:r>
               <a:rPr lang="en-US" sz="1200" b="1" spc="200" kern="0" dirty="0">
                 <a:solidFill>
-                  <a:srgbClr val="C89B3C"/>
+                  <a:srgbClr val="A8452A"/>
                 </a:solidFill>
                 <a:latin typeface="Calibri" pitchFamily="34" charset="0"/>
                 <a:ea typeface="Calibri" pitchFamily="34" charset="-122"/>
@@ -5824,7 +5736,7 @@
       </p:sp>
       <p:sp>
         <p:nvSpPr>
-          <p:cNvPr id="5" name="Text 3"/>
+          <p:cNvPr id="5" name="Text 2"/>
           <p:cNvSpPr txBox="1"/>
           <p:nvPr/>
         </p:nvSpPr>
@@ -5852,7 +5764,7 @@
             <a:r>
               <a:rPr lang="en-US" sz="2700" b="1" dirty="0">
                 <a:solidFill>
-                  <a:srgbClr val="141A35"/>
+                  <a:srgbClr val="253B2C"/>
                 </a:solidFill>
                 <a:latin typeface="Cambria" pitchFamily="34" charset="0"/>
                 <a:ea typeface="Cambria" pitchFamily="34" charset="-122"/>
@@ -5872,7 +5784,7 @@
             <a:r>
               <a:rPr lang="en-US" sz="2700" b="1" dirty="0">
                 <a:solidFill>
-                  <a:srgbClr val="141A35"/>
+                  <a:srgbClr val="253B2C"/>
                 </a:solidFill>
                 <a:latin typeface="Cambria" pitchFamily="34" charset="0"/>
                 <a:ea typeface="Cambria" pitchFamily="34" charset="-122"/>
@@ -5886,7 +5798,7 @@
       </p:sp>
       <p:sp>
         <p:nvSpPr>
-          <p:cNvPr id="6" name="Shape 4"/>
+          <p:cNvPr id="6" name="Shape 3"/>
           <p:cNvSpPr/>
           <p:nvPr/>
         </p:nvSpPr>
@@ -5897,15 +5809,15 @@
           </a:xfrm>
           <a:prstGeom prst="roundRect">
             <a:avLst>
-              <a:gd name="adj" fmla="val 3750"/>
+              <a:gd name="adj" fmla="val 2813"/>
             </a:avLst>
           </a:prstGeom>
           <a:solidFill>
-            <a:srgbClr val="F7F6FC"/>
+            <a:srgbClr val="FFFDF8"/>
           </a:solidFill>
           <a:ln w="12700">
             <a:solidFill>
-              <a:srgbClr val="DAD6EE"/>
+              <a:srgbClr val="DCD0B4"/>
             </a:solidFill>
             <a:prstDash val="solid"/>
           </a:ln>
@@ -5913,7 +5825,7 @@
       </p:sp>
       <p:sp>
         <p:nvSpPr>
-          <p:cNvPr id="7" name="Text 5"/>
+          <p:cNvPr id="7" name="Text 4"/>
           <p:cNvSpPr txBox="1"/>
           <p:nvPr/>
         </p:nvSpPr>
@@ -5938,7 +5850,7 @@
             <a:r>
               <a:rPr lang="en-US" sz="6000" b="1" dirty="0">
                 <a:solidFill>
-                  <a:srgbClr val="E6D6A8"/>
+                  <a:srgbClr val="F3DDD2"/>
                 </a:solidFill>
                 <a:latin typeface="Cambria" pitchFamily="34" charset="0"/>
                 <a:ea typeface="Cambria" pitchFamily="34" charset="-122"/>
@@ -5952,7 +5864,7 @@
       </p:sp>
       <p:sp>
         <p:nvSpPr>
-          <p:cNvPr id="8" name="Text 6"/>
+          <p:cNvPr id="8" name="Text 5"/>
           <p:cNvSpPr txBox="1"/>
           <p:nvPr/>
         </p:nvSpPr>
@@ -5980,7 +5892,7 @@
             <a:r>
               <a:rPr lang="en-US" sz="1400" i="1" dirty="0">
                 <a:solidFill>
-                  <a:srgbClr val="2B2F4A"/>
+                  <a:srgbClr val="201D16"/>
                 </a:solidFill>
                 <a:latin typeface="Calibri" pitchFamily="34" charset="0"/>
                 <a:ea typeface="Calibri" pitchFamily="34" charset="-122"/>
@@ -6000,7 +5912,7 @@
             <a:r>
               <a:rPr lang="en-US" sz="1400" i="1" dirty="0">
                 <a:solidFill>
-                  <a:srgbClr val="2B2F4A"/>
+                  <a:srgbClr val="201D16"/>
                 </a:solidFill>
                 <a:latin typeface="Calibri" pitchFamily="34" charset="0"/>
                 <a:ea typeface="Calibri" pitchFamily="34" charset="-122"/>
@@ -6020,7 +5932,7 @@
             <a:r>
               <a:rPr lang="en-US" sz="1400" i="1" dirty="0">
                 <a:solidFill>
-                  <a:srgbClr val="2B2F4A"/>
+                  <a:srgbClr val="201D16"/>
                 </a:solidFill>
                 <a:latin typeface="Calibri" pitchFamily="34" charset="0"/>
                 <a:ea typeface="Calibri" pitchFamily="34" charset="-122"/>
@@ -6040,7 +5952,7 @@
             <a:r>
               <a:rPr lang="en-US" sz="1400" i="1" dirty="0">
                 <a:solidFill>
-                  <a:srgbClr val="2B2F4A"/>
+                  <a:srgbClr val="201D16"/>
                 </a:solidFill>
                 <a:latin typeface="Calibri" pitchFamily="34" charset="0"/>
                 <a:ea typeface="Calibri" pitchFamily="34" charset="-122"/>
@@ -6069,7 +5981,7 @@
             <a:r>
               <a:rPr lang="en-US" sz="1400" i="1" dirty="0">
                 <a:solidFill>
-                  <a:srgbClr val="2B2F4A"/>
+                  <a:srgbClr val="201D16"/>
                 </a:solidFill>
                 <a:latin typeface="Calibri" pitchFamily="34" charset="0"/>
                 <a:ea typeface="Calibri" pitchFamily="34" charset="-122"/>
@@ -6089,7 +6001,7 @@
             <a:r>
               <a:rPr lang="en-US" sz="1400" i="1" dirty="0">
                 <a:solidFill>
-                  <a:srgbClr val="2B2F4A"/>
+                  <a:srgbClr val="201D16"/>
                 </a:solidFill>
                 <a:latin typeface="Calibri" pitchFamily="34" charset="0"/>
                 <a:ea typeface="Calibri" pitchFamily="34" charset="-122"/>
@@ -6109,7 +6021,7 @@
             <a:r>
               <a:rPr lang="en-US" sz="1400" i="1" dirty="0">
                 <a:solidFill>
-                  <a:srgbClr val="2B2F4A"/>
+                  <a:srgbClr val="201D16"/>
                 </a:solidFill>
                 <a:latin typeface="Calibri" pitchFamily="34" charset="0"/>
                 <a:ea typeface="Calibri" pitchFamily="34" charset="-122"/>
@@ -6123,7 +6035,7 @@
       </p:sp>
       <p:sp>
         <p:nvSpPr>
-          <p:cNvPr id="9" name="Text 7"/>
+          <p:cNvPr id="9" name="Text 6"/>
           <p:cNvSpPr txBox="1"/>
           <p:nvPr/>
         </p:nvSpPr>
@@ -6151,7 +6063,7 @@
             <a:r>
               <a:rPr lang="en-US" sz="1350" dirty="0">
                 <a:solidFill>
-                  <a:srgbClr val="6B7099"/>
+                  <a:srgbClr val="6B6354"/>
                 </a:solidFill>
                 <a:latin typeface="Calibri" pitchFamily="34" charset="0"/>
                 <a:ea typeface="Calibri" pitchFamily="34" charset="-122"/>
@@ -6171,7 +6083,7 @@
             <a:r>
               <a:rPr lang="en-US" sz="1350" dirty="0">
                 <a:solidFill>
-                  <a:srgbClr val="6B7099"/>
+                  <a:srgbClr val="6B6354"/>
                 </a:solidFill>
                 <a:latin typeface="Calibri" pitchFamily="34" charset="0"/>
                 <a:ea typeface="Calibri" pitchFamily="34" charset="-122"/>
@@ -6185,7 +6097,7 @@
       </p:sp>
       <p:sp>
         <p:nvSpPr>
-          <p:cNvPr id="10" name="Text 8"/>
+          <p:cNvPr id="10" name="Text 7"/>
           <p:cNvSpPr txBox="1"/>
           <p:nvPr/>
         </p:nvSpPr>
@@ -6210,7 +6122,7 @@
             <a:r>
               <a:rPr lang="en-US" sz="1000" dirty="0">
                 <a:solidFill>
-                  <a:srgbClr val="6B7099"/>
+                  <a:srgbClr val="8A7C6C"/>
                 </a:solidFill>
                 <a:latin typeface="Calibri" pitchFamily="34" charset="0"/>
                 <a:ea typeface="Calibri" pitchFamily="34" charset="-122"/>
@@ -6236,7 +6148,7 @@
     <p:bg>
       <p:bgPr>
         <a:solidFill>
-          <a:srgbClr val="EDEBF8"/>
+          <a:srgbClr val="F2EAD6"/>
         </a:solidFill>
       </p:bgPr>
     </p:bg>
@@ -6269,34 +6181,38 @@
             <a:avLst/>
           </a:prstGeom>
           <a:solidFill>
-            <a:srgbClr val="C89B3C"/>
+            <a:srgbClr val="E7ECE5"/>
           </a:solidFill>
           <a:ln/>
         </p:spPr>
       </p:sp>
-      <p:sp>
-        <p:nvSpPr>
-          <p:cNvPr id="3" name="Shape 1"/>
-          <p:cNvSpPr/>
-          <p:nvPr/>
-        </p:nvSpPr>
-        <p:spPr>
-          <a:xfrm>
-            <a:off x="672084" y="672084"/>
-            <a:ext cx="210312" cy="210312"/>
-          </a:xfrm>
-          <a:prstGeom prst="star5">
-            <a:avLst/>
-          </a:prstGeom>
-          <a:solidFill>
-            <a:srgbClr val="141A35"/>
-          </a:solidFill>
-          <a:ln/>
-        </p:spPr>
-      </p:sp>
-      <p:sp>
-        <p:nvSpPr>
-          <p:cNvPr id="4" name="Text 2"/>
+      <p:pic>
+        <p:nvPicPr>
+          <p:cNvPr id="3" name="Image 0" descr="mark-onlight.png">    </p:cNvPr>
+          <p:cNvPicPr>
+            <a:picLocks noChangeAspect="1"/>
+          </p:cNvPicPr>
+          <p:nvPr/>
+        </p:nvPicPr>
+        <p:blipFill>
+          <a:blip r:embed="rId1"/>
+          <a:stretch>
+            <a:fillRect/>
+          </a:stretch>
+        </p:blipFill>
+        <p:spPr>
+          <a:xfrm>
+            <a:off x="649224" y="649224"/>
+            <a:ext cx="256032" cy="256032"/>
+          </a:xfrm>
+          <a:prstGeom prst="rect">
+            <a:avLst/>
+          </a:prstGeom>
+        </p:spPr>
+      </p:pic>
+      <p:sp>
+        <p:nvSpPr>
+          <p:cNvPr id="4" name="Text 1"/>
           <p:cNvSpPr txBox="1"/>
           <p:nvPr/>
         </p:nvSpPr>
@@ -6321,7 +6237,7 @@
             <a:r>
               <a:rPr lang="en-US" sz="1200" b="1" spc="200" kern="0" dirty="0">
                 <a:solidFill>
-                  <a:srgbClr val="C89B3C"/>
+                  <a:srgbClr val="A8452A"/>
                 </a:solidFill>
                 <a:latin typeface="Calibri" pitchFamily="34" charset="0"/>
                 <a:ea typeface="Calibri" pitchFamily="34" charset="-122"/>
@@ -6335,7 +6251,7 @@
       </p:sp>
       <p:sp>
         <p:nvSpPr>
-          <p:cNvPr id="5" name="Text 3"/>
+          <p:cNvPr id="5" name="Text 2"/>
           <p:cNvSpPr txBox="1"/>
           <p:nvPr/>
         </p:nvSpPr>
@@ -6363,7 +6279,7 @@
             <a:r>
               <a:rPr lang="en-US" sz="2800" b="1" dirty="0">
                 <a:solidFill>
-                  <a:srgbClr val="141A35"/>
+                  <a:srgbClr val="253B2C"/>
                 </a:solidFill>
                 <a:latin typeface="Cambria" pitchFamily="34" charset="0"/>
                 <a:ea typeface="Cambria" pitchFamily="34" charset="-122"/>
@@ -6383,7 +6299,7 @@
             <a:r>
               <a:rPr lang="en-US" sz="2800" b="1" dirty="0">
                 <a:solidFill>
-                  <a:srgbClr val="141A35"/>
+                  <a:srgbClr val="253B2C"/>
                 </a:solidFill>
                 <a:latin typeface="Cambria" pitchFamily="34" charset="0"/>
                 <a:ea typeface="Cambria" pitchFamily="34" charset="-122"/>
@@ -6403,7 +6319,7 @@
             <a:r>
               <a:rPr lang="en-US" sz="2800" b="1" dirty="0">
                 <a:solidFill>
-                  <a:srgbClr val="141A35"/>
+                  <a:srgbClr val="253B2C"/>
                 </a:solidFill>
                 <a:latin typeface="Cambria" pitchFamily="34" charset="0"/>
                 <a:ea typeface="Cambria" pitchFamily="34" charset="-122"/>
@@ -6417,7 +6333,7 @@
       </p:sp>
       <p:sp>
         <p:nvSpPr>
-          <p:cNvPr id="6" name="Shape 4"/>
+          <p:cNvPr id="6" name="Shape 3"/>
           <p:cNvSpPr/>
           <p:nvPr/>
         </p:nvSpPr>
@@ -6428,18 +6344,18 @@
           </a:xfrm>
           <a:prstGeom prst="roundRect">
             <a:avLst>
-              <a:gd name="adj" fmla="val 19048"/>
+              <a:gd name="adj" fmla="val 14286"/>
             </a:avLst>
           </a:prstGeom>
           <a:solidFill>
-            <a:srgbClr val="141A35"/>
+            <a:srgbClr val="14201A"/>
           </a:solidFill>
           <a:ln/>
         </p:spPr>
       </p:sp>
       <p:sp>
         <p:nvSpPr>
-          <p:cNvPr id="7" name="Text 5"/>
+          <p:cNvPr id="7" name="Text 4"/>
           <p:cNvSpPr txBox="1"/>
           <p:nvPr/>
         </p:nvSpPr>
@@ -6464,7 +6380,7 @@
             <a:r>
               <a:rPr lang="en-US" sz="1600" b="1" dirty="0">
                 <a:solidFill>
-                  <a:srgbClr val="C89B3C"/>
+                  <a:srgbClr val="C25F3D"/>
                 </a:solidFill>
                 <a:latin typeface="Cambria" pitchFamily="34" charset="0"/>
                 <a:ea typeface="Cambria" pitchFamily="34" charset="-122"/>
@@ -6478,7 +6394,7 @@
       </p:sp>
       <p:sp>
         <p:nvSpPr>
-          <p:cNvPr id="8" name="Text 6"/>
+          <p:cNvPr id="8" name="Text 5"/>
           <p:cNvSpPr txBox="1"/>
           <p:nvPr/>
         </p:nvSpPr>
@@ -6503,7 +6419,7 @@
             <a:r>
               <a:rPr lang="en-US" sz="1450" b="1" dirty="0">
                 <a:solidFill>
-                  <a:srgbClr val="141A35"/>
+                  <a:srgbClr val="253B2C"/>
                 </a:solidFill>
                 <a:latin typeface="Calibri" pitchFamily="34" charset="0"/>
                 <a:ea typeface="Calibri" pitchFamily="34" charset="-122"/>
@@ -6517,7 +6433,7 @@
       </p:sp>
       <p:sp>
         <p:nvSpPr>
-          <p:cNvPr id="9" name="Text 7"/>
+          <p:cNvPr id="9" name="Text 6"/>
           <p:cNvSpPr txBox="1"/>
           <p:nvPr/>
         </p:nvSpPr>
@@ -6545,7 +6461,7 @@
             <a:r>
               <a:rPr lang="en-US" sz="1200" dirty="0">
                 <a:solidFill>
-                  <a:srgbClr val="6B7099"/>
+                  <a:srgbClr val="6B6354"/>
                 </a:solidFill>
                 <a:latin typeface="Calibri" pitchFamily="34" charset="0"/>
                 <a:ea typeface="Calibri" pitchFamily="34" charset="-122"/>
@@ -6559,7 +6475,7 @@
       </p:sp>
       <p:sp>
         <p:nvSpPr>
-          <p:cNvPr id="10" name="Shape 8"/>
+          <p:cNvPr id="10" name="Shape 7"/>
           <p:cNvSpPr/>
           <p:nvPr/>
         </p:nvSpPr>
@@ -6570,18 +6486,18 @@
           </a:xfrm>
           <a:prstGeom prst="roundRect">
             <a:avLst>
-              <a:gd name="adj" fmla="val 19048"/>
+              <a:gd name="adj" fmla="val 14286"/>
             </a:avLst>
           </a:prstGeom>
           <a:solidFill>
-            <a:srgbClr val="141A35"/>
+            <a:srgbClr val="14201A"/>
           </a:solidFill>
           <a:ln/>
         </p:spPr>
       </p:sp>
       <p:sp>
         <p:nvSpPr>
-          <p:cNvPr id="11" name="Text 9"/>
+          <p:cNvPr id="11" name="Text 8"/>
           <p:cNvSpPr txBox="1"/>
           <p:nvPr/>
         </p:nvSpPr>
@@ -6606,7 +6522,7 @@
             <a:r>
               <a:rPr lang="en-US" sz="1600" b="1" dirty="0">
                 <a:solidFill>
-                  <a:srgbClr val="C89B3C"/>
+                  <a:srgbClr val="C25F3D"/>
                 </a:solidFill>
                 <a:latin typeface="Cambria" pitchFamily="34" charset="0"/>
                 <a:ea typeface="Cambria" pitchFamily="34" charset="-122"/>
@@ -6620,7 +6536,7 @@
       </p:sp>
       <p:sp>
         <p:nvSpPr>
-          <p:cNvPr id="12" name="Text 10"/>
+          <p:cNvPr id="12" name="Text 9"/>
           <p:cNvSpPr txBox="1"/>
           <p:nvPr/>
         </p:nvSpPr>
@@ -6645,7 +6561,7 @@
             <a:r>
               <a:rPr lang="en-US" sz="1450" b="1" dirty="0">
                 <a:solidFill>
-                  <a:srgbClr val="141A35"/>
+                  <a:srgbClr val="253B2C"/>
                 </a:solidFill>
                 <a:latin typeface="Calibri" pitchFamily="34" charset="0"/>
                 <a:ea typeface="Calibri" pitchFamily="34" charset="-122"/>
@@ -6659,7 +6575,7 @@
       </p:sp>
       <p:sp>
         <p:nvSpPr>
-          <p:cNvPr id="13" name="Text 11"/>
+          <p:cNvPr id="13" name="Text 10"/>
           <p:cNvSpPr txBox="1"/>
           <p:nvPr/>
         </p:nvSpPr>
@@ -6687,7 +6603,7 @@
             <a:r>
               <a:rPr lang="en-US" sz="1200" dirty="0">
                 <a:solidFill>
-                  <a:srgbClr val="6B7099"/>
+                  <a:srgbClr val="6B6354"/>
                 </a:solidFill>
                 <a:latin typeface="Calibri" pitchFamily="34" charset="0"/>
                 <a:ea typeface="Calibri" pitchFamily="34" charset="-122"/>
@@ -6701,7 +6617,7 @@
       </p:sp>
       <p:sp>
         <p:nvSpPr>
-          <p:cNvPr id="14" name="Shape 12"/>
+          <p:cNvPr id="14" name="Shape 11"/>
           <p:cNvSpPr/>
           <p:nvPr/>
         </p:nvSpPr>
@@ -6712,18 +6628,18 @@
           </a:xfrm>
           <a:prstGeom prst="roundRect">
             <a:avLst>
-              <a:gd name="adj" fmla="val 19048"/>
+              <a:gd name="adj" fmla="val 14286"/>
             </a:avLst>
           </a:prstGeom>
           <a:solidFill>
-            <a:srgbClr val="141A35"/>
+            <a:srgbClr val="14201A"/>
           </a:solidFill>
           <a:ln/>
         </p:spPr>
       </p:sp>
       <p:sp>
         <p:nvSpPr>
-          <p:cNvPr id="15" name="Text 13"/>
+          <p:cNvPr id="15" name="Text 12"/>
           <p:cNvSpPr txBox="1"/>
           <p:nvPr/>
         </p:nvSpPr>
@@ -6748,7 +6664,7 @@
             <a:r>
               <a:rPr lang="en-US" sz="1600" b="1" dirty="0">
                 <a:solidFill>
-                  <a:srgbClr val="C89B3C"/>
+                  <a:srgbClr val="C25F3D"/>
                 </a:solidFill>
                 <a:latin typeface="Cambria" pitchFamily="34" charset="0"/>
                 <a:ea typeface="Cambria" pitchFamily="34" charset="-122"/>
@@ -6762,7 +6678,7 @@
       </p:sp>
       <p:sp>
         <p:nvSpPr>
-          <p:cNvPr id="16" name="Text 14"/>
+          <p:cNvPr id="16" name="Text 13"/>
           <p:cNvSpPr txBox="1"/>
           <p:nvPr/>
         </p:nvSpPr>
@@ -6787,7 +6703,7 @@
             <a:r>
               <a:rPr lang="en-US" sz="1450" b="1" dirty="0">
                 <a:solidFill>
-                  <a:srgbClr val="141A35"/>
+                  <a:srgbClr val="253B2C"/>
                 </a:solidFill>
                 <a:latin typeface="Calibri" pitchFamily="34" charset="0"/>
                 <a:ea typeface="Calibri" pitchFamily="34" charset="-122"/>
@@ -6801,7 +6717,7 @@
       </p:sp>
       <p:sp>
         <p:nvSpPr>
-          <p:cNvPr id="17" name="Text 15"/>
+          <p:cNvPr id="17" name="Text 14"/>
           <p:cNvSpPr txBox="1"/>
           <p:nvPr/>
         </p:nvSpPr>
@@ -6829,7 +6745,7 @@
             <a:r>
               <a:rPr lang="en-US" sz="1200" dirty="0">
                 <a:solidFill>
-                  <a:srgbClr val="6B7099"/>
+                  <a:srgbClr val="6B6354"/>
                 </a:solidFill>
                 <a:latin typeface="Calibri" pitchFamily="34" charset="0"/>
                 <a:ea typeface="Calibri" pitchFamily="34" charset="-122"/>
@@ -6843,7 +6759,7 @@
       </p:sp>
       <p:sp>
         <p:nvSpPr>
-          <p:cNvPr id="18" name="Shape 16"/>
+          <p:cNvPr id="18" name="Shape 15"/>
           <p:cNvSpPr/>
           <p:nvPr/>
         </p:nvSpPr>
@@ -6854,18 +6770,18 @@
           </a:xfrm>
           <a:prstGeom prst="roundRect">
             <a:avLst>
-              <a:gd name="adj" fmla="val 19048"/>
+              <a:gd name="adj" fmla="val 14286"/>
             </a:avLst>
           </a:prstGeom>
           <a:solidFill>
-            <a:srgbClr val="141A35"/>
+            <a:srgbClr val="14201A"/>
           </a:solidFill>
           <a:ln/>
         </p:spPr>
       </p:sp>
       <p:sp>
         <p:nvSpPr>
-          <p:cNvPr id="19" name="Text 17"/>
+          <p:cNvPr id="19" name="Text 16"/>
           <p:cNvSpPr txBox="1"/>
           <p:nvPr/>
         </p:nvSpPr>
@@ -6890,7 +6806,7 @@
             <a:r>
               <a:rPr lang="en-US" sz="1600" b="1" dirty="0">
                 <a:solidFill>
-                  <a:srgbClr val="C89B3C"/>
+                  <a:srgbClr val="C25F3D"/>
                 </a:solidFill>
                 <a:latin typeface="Cambria" pitchFamily="34" charset="0"/>
                 <a:ea typeface="Cambria" pitchFamily="34" charset="-122"/>
@@ -6904,7 +6820,7 @@
       </p:sp>
       <p:sp>
         <p:nvSpPr>
-          <p:cNvPr id="20" name="Text 18"/>
+          <p:cNvPr id="20" name="Text 17"/>
           <p:cNvSpPr txBox="1"/>
           <p:nvPr/>
         </p:nvSpPr>
@@ -6929,7 +6845,7 @@
             <a:r>
               <a:rPr lang="en-US" sz="1450" b="1" dirty="0">
                 <a:solidFill>
-                  <a:srgbClr val="141A35"/>
+                  <a:srgbClr val="253B2C"/>
                 </a:solidFill>
                 <a:latin typeface="Calibri" pitchFamily="34" charset="0"/>
                 <a:ea typeface="Calibri" pitchFamily="34" charset="-122"/>
@@ -6943,7 +6859,7 @@
       </p:sp>
       <p:sp>
         <p:nvSpPr>
-          <p:cNvPr id="21" name="Text 19"/>
+          <p:cNvPr id="21" name="Text 18"/>
           <p:cNvSpPr txBox="1"/>
           <p:nvPr/>
         </p:nvSpPr>
@@ -6971,7 +6887,7 @@
             <a:r>
               <a:rPr lang="en-US" sz="1200" dirty="0">
                 <a:solidFill>
-                  <a:srgbClr val="6B7099"/>
+                  <a:srgbClr val="6B6354"/>
                 </a:solidFill>
                 <a:latin typeface="Calibri" pitchFamily="34" charset="0"/>
                 <a:ea typeface="Calibri" pitchFamily="34" charset="-122"/>
@@ -6985,7 +6901,7 @@
       </p:sp>
       <p:sp>
         <p:nvSpPr>
-          <p:cNvPr id="22" name="Shape 20"/>
+          <p:cNvPr id="22" name="Shape 19"/>
           <p:cNvSpPr/>
           <p:nvPr/>
         </p:nvSpPr>
@@ -6996,18 +6912,18 @@
           </a:xfrm>
           <a:prstGeom prst="roundRect">
             <a:avLst>
-              <a:gd name="adj" fmla="val 19048"/>
+              <a:gd name="adj" fmla="val 14286"/>
             </a:avLst>
           </a:prstGeom>
           <a:solidFill>
-            <a:srgbClr val="141A35"/>
+            <a:srgbClr val="14201A"/>
           </a:solidFill>
           <a:ln/>
         </p:spPr>
       </p:sp>
       <p:sp>
         <p:nvSpPr>
-          <p:cNvPr id="23" name="Text 21"/>
+          <p:cNvPr id="23" name="Text 20"/>
           <p:cNvSpPr txBox="1"/>
           <p:nvPr/>
         </p:nvSpPr>
@@ -7032,7 +6948,7 @@
             <a:r>
               <a:rPr lang="en-US" sz="1600" b="1" dirty="0">
                 <a:solidFill>
-                  <a:srgbClr val="C89B3C"/>
+                  <a:srgbClr val="C25F3D"/>
                 </a:solidFill>
                 <a:latin typeface="Cambria" pitchFamily="34" charset="0"/>
                 <a:ea typeface="Cambria" pitchFamily="34" charset="-122"/>
@@ -7046,7 +6962,7 @@
       </p:sp>
       <p:sp>
         <p:nvSpPr>
-          <p:cNvPr id="24" name="Text 22"/>
+          <p:cNvPr id="24" name="Text 21"/>
           <p:cNvSpPr txBox="1"/>
           <p:nvPr/>
         </p:nvSpPr>
@@ -7071,7 +6987,7 @@
             <a:r>
               <a:rPr lang="en-US" sz="1450" b="1" dirty="0">
                 <a:solidFill>
-                  <a:srgbClr val="141A35"/>
+                  <a:srgbClr val="253B2C"/>
                 </a:solidFill>
                 <a:latin typeface="Calibri" pitchFamily="34" charset="0"/>
                 <a:ea typeface="Calibri" pitchFamily="34" charset="-122"/>
@@ -7085,7 +7001,7 @@
       </p:sp>
       <p:sp>
         <p:nvSpPr>
-          <p:cNvPr id="25" name="Text 23"/>
+          <p:cNvPr id="25" name="Text 22"/>
           <p:cNvSpPr txBox="1"/>
           <p:nvPr/>
         </p:nvSpPr>
@@ -7113,7 +7029,7 @@
             <a:r>
               <a:rPr lang="en-US" sz="1200" dirty="0">
                 <a:solidFill>
-                  <a:srgbClr val="6B7099"/>
+                  <a:srgbClr val="6B6354"/>
                 </a:solidFill>
                 <a:latin typeface="Calibri" pitchFamily="34" charset="0"/>
                 <a:ea typeface="Calibri" pitchFamily="34" charset="-122"/>
@@ -7127,7 +7043,7 @@
       </p:sp>
       <p:sp>
         <p:nvSpPr>
-          <p:cNvPr id="26" name="Text 24"/>
+          <p:cNvPr id="26" name="Text 23"/>
           <p:cNvSpPr txBox="1"/>
           <p:nvPr/>
         </p:nvSpPr>
@@ -7152,7 +7068,7 @@
             <a:r>
               <a:rPr lang="en-US" sz="1000" dirty="0">
                 <a:solidFill>
-                  <a:srgbClr val="6B7099"/>
+                  <a:srgbClr val="8A7C6C"/>
                 </a:solidFill>
                 <a:latin typeface="Calibri" pitchFamily="34" charset="0"/>
                 <a:ea typeface="Calibri" pitchFamily="34" charset="-122"/>
@@ -7178,7 +7094,7 @@
     <p:bg>
       <p:bgPr>
         <a:solidFill>
-          <a:srgbClr val="141A35"/>
+          <a:srgbClr val="14201A"/>
         </a:solidFill>
       </p:bgPr>
     </p:bg>
@@ -7204,47 +7120,51 @@
         </p:nvSpPr>
         <p:spPr>
           <a:xfrm>
-            <a:off x="3291840" y="777240"/>
-            <a:ext cx="731520" cy="731520"/>
+            <a:off x="3246120" y="731520"/>
+            <a:ext cx="822960" cy="822960"/>
           </a:xfrm>
           <a:prstGeom prst="ellipse">
             <a:avLst/>
           </a:prstGeom>
           <a:solidFill>
-            <a:srgbClr val="C89B3C"/>
+            <a:srgbClr val="1C2A20"/>
           </a:solidFill>
           <a:ln/>
         </p:spPr>
       </p:sp>
-      <p:sp>
-        <p:nvSpPr>
-          <p:cNvPr id="3" name="Shape 1"/>
-          <p:cNvSpPr/>
-          <p:nvPr/>
-        </p:nvSpPr>
-        <p:spPr>
-          <a:xfrm>
-            <a:off x="3489350" y="974750"/>
-            <a:ext cx="336499" cy="336499"/>
-          </a:xfrm>
-          <a:prstGeom prst="star5">
-            <a:avLst/>
-          </a:prstGeom>
-          <a:solidFill>
-            <a:srgbClr val="141A35"/>
-          </a:solidFill>
-          <a:ln/>
-        </p:spPr>
-      </p:sp>
-      <p:sp>
-        <p:nvSpPr>
-          <p:cNvPr id="4" name="Text 2"/>
-          <p:cNvSpPr txBox="1"/>
-          <p:nvPr/>
-        </p:nvSpPr>
-        <p:spPr>
-          <a:xfrm>
-            <a:off x="548640" y="1828800"/>
+      <p:pic>
+        <p:nvPicPr>
+          <p:cNvPr id="3" name="Image 0" descr="mark-ondark.png">    </p:cNvPr>
+          <p:cNvPicPr>
+            <a:picLocks noChangeAspect="1"/>
+          </p:cNvPicPr>
+          <p:nvPr/>
+        </p:nvPicPr>
+        <p:blipFill>
+          <a:blip r:embed="rId1"/>
+          <a:stretch>
+            <a:fillRect/>
+          </a:stretch>
+        </p:blipFill>
+        <p:spPr>
+          <a:xfrm>
+            <a:off x="3427171" y="912571"/>
+            <a:ext cx="460858" cy="460858"/>
+          </a:xfrm>
+          <a:prstGeom prst="rect">
+            <a:avLst/>
+          </a:prstGeom>
+        </p:spPr>
+      </p:pic>
+      <p:sp>
+        <p:nvSpPr>
+          <p:cNvPr id="4" name="Text 1"/>
+          <p:cNvSpPr txBox="1"/>
+          <p:nvPr/>
+        </p:nvSpPr>
+        <p:spPr>
+          <a:xfrm>
+            <a:off x="548640" y="1783080"/>
             <a:ext cx="6217920" cy="365760"/>
           </a:xfrm>
           <a:prstGeom prst="rect">
@@ -7263,7 +7183,7 @@
             <a:r>
               <a:rPr lang="en-US" sz="1300" b="1" spc="300" kern="0" dirty="0">
                 <a:solidFill>
-                  <a:srgbClr val="E6D6A8"/>
+                  <a:srgbClr val="C25F3D"/>
                 </a:solidFill>
                 <a:latin typeface="Calibri" pitchFamily="34" charset="0"/>
                 <a:ea typeface="Calibri" pitchFamily="34" charset="-122"/>
@@ -7277,13 +7197,13 @@
       </p:sp>
       <p:sp>
         <p:nvSpPr>
-          <p:cNvPr id="5" name="Text 3"/>
-          <p:cNvSpPr txBox="1"/>
-          <p:nvPr/>
-        </p:nvSpPr>
-        <p:spPr>
-          <a:xfrm>
-            <a:off x="548640" y="2331720"/>
+          <p:cNvPr id="5" name="Text 2"/>
+          <p:cNvSpPr txBox="1"/>
+          <p:nvPr/>
+        </p:nvSpPr>
+        <p:spPr>
+          <a:xfrm>
+            <a:off x="548640" y="2286000"/>
             <a:ext cx="6217920" cy="1463040"/>
           </a:xfrm>
           <a:prstGeom prst="rect">
@@ -7305,7 +7225,7 @@
             <a:r>
               <a:rPr lang="en-US" sz="3400" b="1" dirty="0">
                 <a:solidFill>
-                  <a:srgbClr val="FFFFFF"/>
+                  <a:srgbClr val="F2EAD6"/>
                 </a:solidFill>
                 <a:latin typeface="Cambria" pitchFamily="34" charset="0"/>
                 <a:ea typeface="Cambria" pitchFamily="34" charset="-122"/>
@@ -7325,7 +7245,7 @@
             <a:r>
               <a:rPr lang="en-US" sz="3400" b="1" dirty="0">
                 <a:solidFill>
-                  <a:srgbClr val="FFFFFF"/>
+                  <a:srgbClr val="F2EAD6"/>
                 </a:solidFill>
                 <a:latin typeface="Cambria" pitchFamily="34" charset="0"/>
                 <a:ea typeface="Cambria" pitchFamily="34" charset="-122"/>
@@ -7339,13 +7259,13 @@
       </p:sp>
       <p:sp>
         <p:nvSpPr>
-          <p:cNvPr id="6" name="Text 4"/>
-          <p:cNvSpPr txBox="1"/>
-          <p:nvPr/>
-        </p:nvSpPr>
-        <p:spPr>
-          <a:xfrm>
-            <a:off x="548640" y="3749040"/>
+          <p:cNvPr id="6" name="Text 3"/>
+          <p:cNvSpPr txBox="1"/>
+          <p:nvPr/>
+        </p:nvSpPr>
+        <p:spPr>
+          <a:xfrm>
+            <a:off x="548640" y="3703320"/>
             <a:ext cx="6217920" cy="1371600"/>
           </a:xfrm>
           <a:prstGeom prst="rect">
@@ -7367,7 +7287,7 @@
             <a:r>
               <a:rPr lang="en-US" sz="3400" b="1" dirty="0">
                 <a:solidFill>
-                  <a:srgbClr val="C89B3C"/>
+                  <a:srgbClr val="C25F3D"/>
                 </a:solidFill>
                 <a:latin typeface="Cambria" pitchFamily="34" charset="0"/>
                 <a:ea typeface="Cambria" pitchFamily="34" charset="-122"/>
@@ -7387,7 +7307,7 @@
             <a:r>
               <a:rPr lang="en-US" sz="3400" b="1" dirty="0">
                 <a:solidFill>
-                  <a:srgbClr val="C89B3C"/>
+                  <a:srgbClr val="C25F3D"/>
                 </a:solidFill>
                 <a:latin typeface="Cambria" pitchFamily="34" charset="0"/>
                 <a:ea typeface="Cambria" pitchFamily="34" charset="-122"/>
@@ -7401,33 +7321,33 @@
       </p:sp>
       <p:sp>
         <p:nvSpPr>
-          <p:cNvPr id="7" name="Shape 5"/>
+          <p:cNvPr id="7" name="Shape 4"/>
           <p:cNvSpPr/>
           <p:nvPr/>
         </p:nvSpPr>
         <p:spPr>
           <a:xfrm>
-            <a:off x="1371600" y="5669280"/>
+            <a:off x="1371600" y="5623560"/>
             <a:ext cx="91440" cy="91440"/>
           </a:xfrm>
           <a:prstGeom prst="ellipse">
             <a:avLst/>
           </a:prstGeom>
           <a:solidFill>
-            <a:srgbClr val="C89B3C"/>
+            <a:srgbClr val="C25F3D"/>
           </a:solidFill>
           <a:ln/>
         </p:spPr>
       </p:sp>
       <p:sp>
         <p:nvSpPr>
-          <p:cNvPr id="8" name="Text 6"/>
-          <p:cNvSpPr txBox="1"/>
-          <p:nvPr/>
-        </p:nvSpPr>
-        <p:spPr>
-          <a:xfrm>
-            <a:off x="1600200" y="5513832"/>
+          <p:cNvPr id="8" name="Text 5"/>
+          <p:cNvSpPr txBox="1"/>
+          <p:nvPr/>
+        </p:nvSpPr>
+        <p:spPr>
+          <a:xfrm>
+            <a:off x="1600200" y="5468112"/>
             <a:ext cx="4114800" cy="365760"/>
           </a:xfrm>
           <a:prstGeom prst="rect">
@@ -7446,7 +7366,7 @@
             <a:r>
               <a:rPr lang="en-US" sz="1300" dirty="0">
                 <a:solidFill>
-                  <a:srgbClr val="E9E7F5"/>
+                  <a:srgbClr val="D8CFB8"/>
                 </a:solidFill>
                 <a:latin typeface="Calibri" pitchFamily="34" charset="0"/>
                 <a:ea typeface="Calibri" pitchFamily="34" charset="-122"/>
@@ -7460,33 +7380,33 @@
       </p:sp>
       <p:sp>
         <p:nvSpPr>
-          <p:cNvPr id="9" name="Shape 7"/>
+          <p:cNvPr id="9" name="Shape 6"/>
           <p:cNvSpPr/>
           <p:nvPr/>
         </p:nvSpPr>
         <p:spPr>
           <a:xfrm>
-            <a:off x="1371600" y="6126480"/>
+            <a:off x="1371600" y="6080760"/>
             <a:ext cx="91440" cy="91440"/>
           </a:xfrm>
           <a:prstGeom prst="ellipse">
             <a:avLst/>
           </a:prstGeom>
           <a:solidFill>
-            <a:srgbClr val="C89B3C"/>
+            <a:srgbClr val="C25F3D"/>
           </a:solidFill>
           <a:ln/>
         </p:spPr>
       </p:sp>
       <p:sp>
         <p:nvSpPr>
-          <p:cNvPr id="10" name="Text 8"/>
-          <p:cNvSpPr txBox="1"/>
-          <p:nvPr/>
-        </p:nvSpPr>
-        <p:spPr>
-          <a:xfrm>
-            <a:off x="1600200" y="5971032"/>
+          <p:cNvPr id="10" name="Text 7"/>
+          <p:cNvSpPr txBox="1"/>
+          <p:nvPr/>
+        </p:nvSpPr>
+        <p:spPr>
+          <a:xfrm>
+            <a:off x="1600200" y="5925312"/>
             <a:ext cx="4114800" cy="365760"/>
           </a:xfrm>
           <a:prstGeom prst="rect">
@@ -7505,7 +7425,7 @@
             <a:r>
               <a:rPr lang="en-US" sz="1300" dirty="0">
                 <a:solidFill>
-                  <a:srgbClr val="E9E7F5"/>
+                  <a:srgbClr val="D8CFB8"/>
                 </a:solidFill>
                 <a:latin typeface="Calibri" pitchFamily="34" charset="0"/>
                 <a:ea typeface="Calibri" pitchFamily="34" charset="-122"/>
@@ -7519,33 +7439,33 @@
       </p:sp>
       <p:sp>
         <p:nvSpPr>
-          <p:cNvPr id="11" name="Shape 9"/>
+          <p:cNvPr id="11" name="Shape 8"/>
           <p:cNvSpPr/>
           <p:nvPr/>
         </p:nvSpPr>
         <p:spPr>
           <a:xfrm>
-            <a:off x="1371600" y="6583680"/>
+            <a:off x="1371600" y="6537960"/>
             <a:ext cx="91440" cy="91440"/>
           </a:xfrm>
           <a:prstGeom prst="ellipse">
             <a:avLst/>
           </a:prstGeom>
           <a:solidFill>
-            <a:srgbClr val="C89B3C"/>
+            <a:srgbClr val="C25F3D"/>
           </a:solidFill>
           <a:ln/>
         </p:spPr>
       </p:sp>
       <p:sp>
         <p:nvSpPr>
-          <p:cNvPr id="12" name="Text 10"/>
-          <p:cNvSpPr txBox="1"/>
-          <p:nvPr/>
-        </p:nvSpPr>
-        <p:spPr>
-          <a:xfrm>
-            <a:off x="1600200" y="6428232"/>
+          <p:cNvPr id="12" name="Text 9"/>
+          <p:cNvSpPr txBox="1"/>
+          <p:nvPr/>
+        </p:nvSpPr>
+        <p:spPr>
+          <a:xfrm>
+            <a:off x="1600200" y="6382512"/>
             <a:ext cx="4114800" cy="365760"/>
           </a:xfrm>
           <a:prstGeom prst="rect">
@@ -7564,7 +7484,7 @@
             <a:r>
               <a:rPr lang="en-US" sz="1300" dirty="0">
                 <a:solidFill>
-                  <a:srgbClr val="E9E7F5"/>
+                  <a:srgbClr val="D8CFB8"/>
                 </a:solidFill>
                 <a:latin typeface="Calibri" pitchFamily="34" charset="0"/>
                 <a:ea typeface="Calibri" pitchFamily="34" charset="-122"/>
@@ -7578,33 +7498,33 @@
       </p:sp>
       <p:sp>
         <p:nvSpPr>
-          <p:cNvPr id="13" name="Shape 11"/>
+          <p:cNvPr id="13" name="Shape 10"/>
           <p:cNvSpPr/>
           <p:nvPr/>
         </p:nvSpPr>
         <p:spPr>
           <a:xfrm>
-            <a:off x="1371600" y="7040880"/>
+            <a:off x="1371600" y="6995160"/>
             <a:ext cx="91440" cy="91440"/>
           </a:xfrm>
           <a:prstGeom prst="ellipse">
             <a:avLst/>
           </a:prstGeom>
           <a:solidFill>
-            <a:srgbClr val="C89B3C"/>
+            <a:srgbClr val="C25F3D"/>
           </a:solidFill>
           <a:ln/>
         </p:spPr>
       </p:sp>
       <p:sp>
         <p:nvSpPr>
-          <p:cNvPr id="14" name="Text 12"/>
-          <p:cNvSpPr txBox="1"/>
-          <p:nvPr/>
-        </p:nvSpPr>
-        <p:spPr>
-          <a:xfrm>
-            <a:off x="1600200" y="6885432"/>
+          <p:cNvPr id="14" name="Text 11"/>
+          <p:cNvSpPr txBox="1"/>
+          <p:nvPr/>
+        </p:nvSpPr>
+        <p:spPr>
+          <a:xfrm>
+            <a:off x="1600200" y="6839712"/>
             <a:ext cx="4114800" cy="365760"/>
           </a:xfrm>
           <a:prstGeom prst="rect">
@@ -7623,7 +7543,7 @@
             <a:r>
               <a:rPr lang="en-US" sz="1300" dirty="0">
                 <a:solidFill>
-                  <a:srgbClr val="E9E7F5"/>
+                  <a:srgbClr val="D8CFB8"/>
                 </a:solidFill>
                 <a:latin typeface="Calibri" pitchFamily="34" charset="0"/>
                 <a:ea typeface="Calibri" pitchFamily="34" charset="-122"/>
@@ -7637,7 +7557,7 @@
       </p:sp>
       <p:sp>
         <p:nvSpPr>
-          <p:cNvPr id="15" name="Text 13"/>
+          <p:cNvPr id="15" name="Text 12"/>
           <p:cNvSpPr txBox="1"/>
           <p:nvPr/>
         </p:nvSpPr>
@@ -7662,7 +7582,7 @@
             <a:r>
               <a:rPr lang="en-US" sz="1000" dirty="0">
                 <a:solidFill>
-                  <a:srgbClr val="7B81AE"/>
+                  <a:srgbClr val="9AA894"/>
                 </a:solidFill>
                 <a:latin typeface="Calibri" pitchFamily="34" charset="0"/>
                 <a:ea typeface="Calibri" pitchFamily="34" charset="-122"/>

</xml_diff>

<commit_message>
Sharpen carousel to match v6 article: drop vanity-stat slide, fix passive-income wording
Co-Authored-By: Claude Sonnet 5 <noreply@anthropic.com>
Claude-Session: https://claude.ai/code/session_01RP8rCVarvEGjpHDYnFJ3xW
</commit_message>
<xml_diff>
--- a/linkedin-carousel.pptx
+++ b/linkedin-carousel.pptx
@@ -2709,34 +2709,103 @@
       </p:sp>
       <p:sp>
         <p:nvSpPr>
-          <p:cNvPr id="9" name="Shape 6"/>
+          <p:cNvPr id="9" name="Text 6"/>
+          <p:cNvSpPr txBox="1"/>
+          <p:nvPr/>
+        </p:nvSpPr>
+        <p:spPr>
+          <a:xfrm>
+            <a:off x="548640" y="5349240"/>
+            <a:ext cx="6217920" cy="777240"/>
+          </a:xfrm>
+          <a:prstGeom prst="rect">
+            <a:avLst/>
+          </a:prstGeom>
+          <a:noFill/>
+          <a:ln/>
+        </p:spPr>
+        <p:txBody>
+          <a:bodyPr wrap="square" lIns="0" tIns="0" rIns="0" bIns="0" rtlCol="0" anchor="ctr"/>
+          <a:lstStyle/>
+          <a:p>
+            <a:pPr indent="0" marL="0">
+              <a:lnSpc>
+                <a:spcPts val="1900"/>
+              </a:lnSpc>
+              <a:buNone/>
+            </a:pPr>
+            <a:r>
+              <a:rPr lang="en-US" sz="1450" dirty="0">
+                <a:solidFill>
+                  <a:srgbClr val="201D16"/>
+                </a:solidFill>
+                <a:latin typeface="Calibri" pitchFamily="34" charset="0"/>
+                <a:ea typeface="Calibri" pitchFamily="34" charset="-122"/>
+                <a:cs typeface="Calibri" pitchFamily="34" charset="-120"/>
+              </a:rPr>
+              <a:t>4 days from the first commit to a live site taking</a:t>
+            </a:r>
+            <a:endParaRPr lang="en-US" sz="1450" dirty="0"/>
+          </a:p>
+          <a:p>
+            <a:pPr indent="0" marL="0">
+              <a:lnSpc>
+                <a:spcPts val="1900"/>
+              </a:lnSpc>
+              <a:buNone/>
+            </a:pPr>
+            <a:r>
+              <a:rPr lang="en-US" sz="1450" dirty="0">
+                <a:solidFill>
+                  <a:srgbClr val="201D16"/>
+                </a:solidFill>
+                <a:latin typeface="Calibri" pitchFamily="34" charset="0"/>
+                <a:ea typeface="Calibri" pitchFamily="34" charset="-122"/>
+                <a:cs typeface="Calibri" pitchFamily="34" charset="-120"/>
+              </a:rPr>
+              <a:t>real payments. Then weeks of relentless refinement.</a:t>
+            </a:r>
+            <a:endParaRPr lang="en-US" sz="1450" dirty="0"/>
+          </a:p>
+        </p:txBody>
+      </p:sp>
+      <p:sp>
+        <p:nvSpPr>
+          <p:cNvPr id="10" name="Shape 7"/>
           <p:cNvSpPr/>
           <p:nvPr/>
         </p:nvSpPr>
         <p:spPr>
           <a:xfrm>
-            <a:off x="548640" y="5404104"/>
-            <a:ext cx="109728" cy="109728"/>
-          </a:xfrm>
-          <a:prstGeom prst="ellipse">
-            <a:avLst/>
+            <a:off x="548640" y="6355080"/>
+            <a:ext cx="6217920" cy="1371600"/>
+          </a:xfrm>
+          <a:prstGeom prst="roundRect">
+            <a:avLst>
+              <a:gd name="adj" fmla="val 4000"/>
+            </a:avLst>
           </a:prstGeom>
           <a:solidFill>
-            <a:srgbClr val="A8452A"/>
+            <a:srgbClr val="FFFDF8"/>
           </a:solidFill>
-          <a:ln/>
-        </p:spPr>
-      </p:sp>
-      <p:sp>
-        <p:nvSpPr>
-          <p:cNvPr id="10" name="Text 7"/>
-          <p:cNvSpPr txBox="1"/>
-          <p:nvPr/>
-        </p:nvSpPr>
-        <p:spPr>
-          <a:xfrm>
-            <a:off x="868680" y="5239512"/>
-            <a:ext cx="5897880" cy="502920"/>
+          <a:ln w="12700">
+            <a:solidFill>
+              <a:srgbClr val="DCD0B4"/>
+            </a:solidFill>
+            <a:prstDash val="solid"/>
+          </a:ln>
+        </p:spPr>
+      </p:sp>
+      <p:sp>
+        <p:nvSpPr>
+          <p:cNvPr id="11" name="Text 8"/>
+          <p:cNvSpPr txBox="1"/>
+          <p:nvPr/>
+        </p:nvSpPr>
+        <p:spPr>
+          <a:xfrm>
+            <a:off x="777240" y="6510528"/>
+            <a:ext cx="5760720" cy="1097280"/>
           </a:xfrm>
           <a:prstGeom prst="rect">
             <a:avLst/>
@@ -2750,152 +2819,68 @@
           <a:p>
             <a:pPr indent="0" marL="0">
               <a:lnSpc>
-                <a:spcPts val="1900"/>
-              </a:lnSpc>
-              <a:buNone/>
-            </a:pPr>
-            <a:r>
-              <a:rPr lang="en-US" sz="1450" dirty="0">
-                <a:solidFill>
-                  <a:srgbClr val="201D16"/>
-                </a:solidFill>
-                <a:latin typeface="Calibri" pitchFamily="34" charset="0"/>
-                <a:ea typeface="Calibri" pitchFamily="34" charset="-122"/>
-                <a:cs typeface="Calibri" pitchFamily="34" charset="-120"/>
-              </a:rPr>
-              <a:t>Nearly a third of all code changes landed between 10pm and 5am</a:t>
-            </a:r>
-            <a:endParaRPr lang="en-US" sz="1450" dirty="0"/>
-          </a:p>
-        </p:txBody>
-      </p:sp>
-      <p:sp>
-        <p:nvSpPr>
-          <p:cNvPr id="11" name="Shape 8"/>
-          <p:cNvSpPr/>
-          <p:nvPr/>
-        </p:nvSpPr>
-        <p:spPr>
-          <a:xfrm>
-            <a:off x="548640" y="6117336"/>
-            <a:ext cx="109728" cy="109728"/>
-          </a:xfrm>
-          <a:prstGeom prst="ellipse">
-            <a:avLst/>
-          </a:prstGeom>
-          <a:solidFill>
-            <a:srgbClr val="A8452A"/>
-          </a:solidFill>
-          <a:ln/>
-        </p:spPr>
+                <a:spcPts val="1800"/>
+              </a:lnSpc>
+              <a:buNone/>
+            </a:pPr>
+            <a:r>
+              <a:rPr lang="en-US" sz="1300" i="1" dirty="0">
+                <a:solidFill>
+                  <a:srgbClr val="6B6354"/>
+                </a:solidFill>
+                <a:latin typeface="Calibri" pitchFamily="34" charset="0"/>
+                <a:ea typeface="Calibri" pitchFamily="34" charset="-122"/>
+                <a:cs typeface="Calibri" pitchFamily="34" charset="-120"/>
+              </a:rPr>
+              <a:t>None of those numbers are the point on their own.</a:t>
+            </a:r>
+            <a:endParaRPr lang="en-US" sz="1300" dirty="0"/>
+          </a:p>
+          <a:p>
+            <a:pPr indent="0" marL="0">
+              <a:lnSpc>
+                <a:spcPts val="1800"/>
+              </a:lnSpc>
+              <a:buNone/>
+            </a:pPr>
+            <a:r>
+              <a:rPr lang="en-US" sz="1300" i="1" dirty="0">
+                <a:solidFill>
+                  <a:srgbClr val="6B6354"/>
+                </a:solidFill>
+                <a:latin typeface="Calibri" pitchFamily="34" charset="0"/>
+                <a:ea typeface="Calibri" pitchFamily="34" charset="-122"/>
+                <a:cs typeface="Calibri" pitchFamily="34" charset="-120"/>
+              </a:rPr>
+              <a:t>What they add up to: every one of them came from a</a:t>
+            </a:r>
+            <a:endParaRPr lang="en-US" sz="1300" dirty="0"/>
+          </a:p>
+          <a:p>
+            <a:pPr indent="0" marL="0">
+              <a:lnSpc>
+                <a:spcPts val="1800"/>
+              </a:lnSpc>
+              <a:buNone/>
+            </a:pPr>
+            <a:r>
+              <a:rPr lang="en-US" sz="1300" i="1" dirty="0">
+                <a:solidFill>
+                  <a:srgbClr val="6B6354"/>
+                </a:solidFill>
+                <a:latin typeface="Calibri" pitchFamily="34" charset="0"/>
+                <a:ea typeface="Calibri" pitchFamily="34" charset="-122"/>
+                <a:cs typeface="Calibri" pitchFamily="34" charset="-120"/>
+              </a:rPr>
+              <a:t>real decision I made — not a default the AI picked for me.</a:t>
+            </a:r>
+            <a:endParaRPr lang="en-US" sz="1300" dirty="0"/>
+          </a:p>
+        </p:txBody>
       </p:sp>
       <p:sp>
         <p:nvSpPr>
           <p:cNvPr id="12" name="Text 9"/>
-          <p:cNvSpPr txBox="1"/>
-          <p:nvPr/>
-        </p:nvSpPr>
-        <p:spPr>
-          <a:xfrm>
-            <a:off x="868680" y="5952744"/>
-            <a:ext cx="5897880" cy="502920"/>
-          </a:xfrm>
-          <a:prstGeom prst="rect">
-            <a:avLst/>
-          </a:prstGeom>
-          <a:noFill/>
-          <a:ln/>
-        </p:spPr>
-        <p:txBody>
-          <a:bodyPr wrap="square" lIns="0" tIns="0" rIns="0" bIns="0" rtlCol="0" anchor="ctr"/>
-          <a:lstStyle/>
-          <a:p>
-            <a:pPr indent="0" marL="0">
-              <a:lnSpc>
-                <a:spcPts val="1900"/>
-              </a:lnSpc>
-              <a:buNone/>
-            </a:pPr>
-            <a:r>
-              <a:rPr lang="en-US" sz="1450" dirty="0">
-                <a:solidFill>
-                  <a:srgbClr val="201D16"/>
-                </a:solidFill>
-                <a:latin typeface="Calibri" pitchFamily="34" charset="0"/>
-                <a:ea typeface="Calibri" pitchFamily="34" charset="-122"/>
-                <a:cs typeface="Calibri" pitchFamily="34" charset="-120"/>
-              </a:rPr>
-              <a:t>Fitted around a full-time job and family — not a sabbatical</a:t>
-            </a:r>
-            <a:endParaRPr lang="en-US" sz="1450" dirty="0"/>
-          </a:p>
-        </p:txBody>
-      </p:sp>
-      <p:sp>
-        <p:nvSpPr>
-          <p:cNvPr id="13" name="Shape 10"/>
-          <p:cNvSpPr/>
-          <p:nvPr/>
-        </p:nvSpPr>
-        <p:spPr>
-          <a:xfrm>
-            <a:off x="548640" y="6830568"/>
-            <a:ext cx="109728" cy="109728"/>
-          </a:xfrm>
-          <a:prstGeom prst="ellipse">
-            <a:avLst/>
-          </a:prstGeom>
-          <a:solidFill>
-            <a:srgbClr val="A8452A"/>
-          </a:solidFill>
-          <a:ln/>
-        </p:spPr>
-      </p:sp>
-      <p:sp>
-        <p:nvSpPr>
-          <p:cNvPr id="14" name="Text 11"/>
-          <p:cNvSpPr txBox="1"/>
-          <p:nvPr/>
-        </p:nvSpPr>
-        <p:spPr>
-          <a:xfrm>
-            <a:off x="868680" y="6665976"/>
-            <a:ext cx="5897880" cy="502920"/>
-          </a:xfrm>
-          <a:prstGeom prst="rect">
-            <a:avLst/>
-          </a:prstGeom>
-          <a:noFill/>
-          <a:ln/>
-        </p:spPr>
-        <p:txBody>
-          <a:bodyPr wrap="square" lIns="0" tIns="0" rIns="0" bIns="0" rtlCol="0" anchor="ctr"/>
-          <a:lstStyle/>
-          <a:p>
-            <a:pPr indent="0" marL="0">
-              <a:lnSpc>
-                <a:spcPts val="1900"/>
-              </a:lnSpc>
-              <a:buNone/>
-            </a:pPr>
-            <a:r>
-              <a:rPr lang="en-US" sz="1450" dirty="0">
-                <a:solidFill>
-                  <a:srgbClr val="201D16"/>
-                </a:solidFill>
-                <a:latin typeface="Calibri" pitchFamily="34" charset="0"/>
-                <a:ea typeface="Calibri" pitchFamily="34" charset="-122"/>
-                <a:cs typeface="Calibri" pitchFamily="34" charset="-120"/>
-              </a:rPr>
-              <a:t>4 days from the first commit to a live site taking real payments</a:t>
-            </a:r>
-            <a:endParaRPr lang="en-US" sz="1450" dirty="0"/>
-          </a:p>
-        </p:txBody>
-      </p:sp>
-      <p:sp>
-        <p:nvSpPr>
-          <p:cNvPr id="15" name="Text 12"/>
           <p:cNvSpPr txBox="1"/>
           <p:nvPr/>
         </p:nvSpPr>
@@ -3041,7 +3026,7 @@
                 <a:ea typeface="Calibri" pitchFamily="34" charset="-122"/>
                 <a:cs typeface="Calibri" pitchFamily="34" charset="-120"/>
               </a:rPr>
-              <a:t>THE BUILD, BY THE NUMBERS</a:t>
+              <a:t>WORKED THROUGH, NOT SKIPPED</a:t>
             </a:r>
             <a:endParaRPr lang="en-US" sz="1200" dirty="0"/>
           </a:p>
@@ -3056,7 +3041,7 @@
         <p:spPr>
           <a:xfrm>
             <a:off x="548640" y="1234440"/>
-            <a:ext cx="6217920" cy="548640"/>
+            <a:ext cx="6217920" cy="1188720"/>
           </a:xfrm>
           <a:prstGeom prst="rect">
             <a:avLst/>
@@ -3069,10 +3054,13 @@
           <a:lstStyle/>
           <a:p>
             <a:pPr indent="0" marL="0">
-              <a:buNone/>
-            </a:pPr>
-            <a:r>
-              <a:rPr lang="en-US" sz="2800" b="1" dirty="0">
+              <a:lnSpc>
+                <a:spcPts val="3400"/>
+              </a:lnSpc>
+              <a:buNone/>
+            </a:pPr>
+            <a:r>
+              <a:rPr lang="en-US" sz="3000" b="1" dirty="0">
                 <a:solidFill>
                   <a:srgbClr val="253B2C"/>
                 </a:solidFill>
@@ -3080,65 +3068,19 @@
                 <a:ea typeface="Cambria" pitchFamily="34" charset="-122"/>
                 <a:cs typeface="Cambria" pitchFamily="34" charset="-120"/>
               </a:rPr>
-              <a:t>Not a weekend project</a:t>
-            </a:r>
-            <a:endParaRPr lang="en-US" sz="2800" dirty="0"/>
-          </a:p>
-        </p:txBody>
-      </p:sp>
-      <p:sp>
-        <p:nvSpPr>
-          <p:cNvPr id="6" name="Shape 3"/>
-          <p:cNvSpPr/>
-          <p:nvPr/>
-        </p:nvSpPr>
-        <p:spPr>
-          <a:xfrm>
-            <a:off x="548640" y="2148840"/>
-            <a:ext cx="2948940" cy="1828800"/>
-          </a:xfrm>
-          <a:prstGeom prst="roundRect">
-            <a:avLst>
-              <a:gd name="adj" fmla="val 3000"/>
-            </a:avLst>
-          </a:prstGeom>
-          <a:solidFill>
-            <a:srgbClr val="FFFDF8"/>
-          </a:solidFill>
-          <a:ln w="12700">
-            <a:solidFill>
-              <a:srgbClr val="DCD0B4"/>
-            </a:solidFill>
-            <a:prstDash val="solid"/>
-          </a:ln>
-        </p:spPr>
-      </p:sp>
-      <p:sp>
-        <p:nvSpPr>
-          <p:cNvPr id="7" name="Text 4"/>
-          <p:cNvSpPr txBox="1"/>
-          <p:nvPr/>
-        </p:nvSpPr>
-        <p:spPr>
-          <a:xfrm>
-            <a:off x="777240" y="2350008"/>
-            <a:ext cx="2491740" cy="685800"/>
-          </a:xfrm>
-          <a:prstGeom prst="rect">
-            <a:avLst/>
-          </a:prstGeom>
-          <a:noFill/>
-          <a:ln/>
-        </p:spPr>
-        <p:txBody>
-          <a:bodyPr wrap="square" lIns="0" tIns="0" rIns="0" bIns="0" rtlCol="0" anchor="ctr"/>
-          <a:lstStyle/>
+              <a:t>The unglamorous</a:t>
+            </a:r>
+            <a:endParaRPr lang="en-US" sz="3000" dirty="0"/>
+          </a:p>
           <a:p>
             <a:pPr indent="0" marL="0">
-              <a:buNone/>
-            </a:pPr>
-            <a:r>
-              <a:rPr lang="en-US" sz="3200" b="1" dirty="0">
+              <a:lnSpc>
+                <a:spcPts val="3400"/>
+              </a:lnSpc>
+              <a:buNone/>
+            </a:pPr>
+            <a:r>
+              <a:rPr lang="en-US" sz="3000" b="1" dirty="0">
                 <a:solidFill>
                   <a:srgbClr val="253B2C"/>
                 </a:solidFill>
@@ -3146,9 +3088,68 @@
                 <a:ea typeface="Cambria" pitchFamily="34" charset="-122"/>
                 <a:cs typeface="Cambria" pitchFamily="34" charset="-120"/>
               </a:rPr>
-              <a:t>~15,000</a:t>
-            </a:r>
-            <a:endParaRPr lang="en-US" sz="3200" dirty="0"/>
+              <a:t>half of the build</a:t>
+            </a:r>
+            <a:endParaRPr lang="en-US" sz="3000" dirty="0"/>
+          </a:p>
+        </p:txBody>
+      </p:sp>
+      <p:sp>
+        <p:nvSpPr>
+          <p:cNvPr id="6" name="Shape 3"/>
+          <p:cNvSpPr/>
+          <p:nvPr/>
+        </p:nvSpPr>
+        <p:spPr>
+          <a:xfrm>
+            <a:off x="548640" y="2651760"/>
+            <a:ext cx="128016" cy="128016"/>
+          </a:xfrm>
+          <a:prstGeom prst="ellipse">
+            <a:avLst/>
+          </a:prstGeom>
+          <a:solidFill>
+            <a:srgbClr val="A8452A"/>
+          </a:solidFill>
+          <a:ln/>
+        </p:spPr>
+      </p:sp>
+      <p:sp>
+        <p:nvSpPr>
+          <p:cNvPr id="7" name="Text 4"/>
+          <p:cNvSpPr txBox="1"/>
+          <p:nvPr/>
+        </p:nvSpPr>
+        <p:spPr>
+          <a:xfrm>
+            <a:off x="868680" y="2523744"/>
+            <a:ext cx="5897880" cy="320040"/>
+          </a:xfrm>
+          <a:prstGeom prst="rect">
+            <a:avLst/>
+          </a:prstGeom>
+          <a:noFill/>
+          <a:ln/>
+        </p:spPr>
+        <p:txBody>
+          <a:bodyPr wrap="square" lIns="0" tIns="0" rIns="0" bIns="0" rtlCol="0" anchor="ctr"/>
+          <a:lstStyle/>
+          <a:p>
+            <a:pPr indent="0" marL="0">
+              <a:buNone/>
+            </a:pPr>
+            <a:r>
+              <a:rPr lang="en-US" sz="1500" b="1" dirty="0">
+                <a:solidFill>
+                  <a:srgbClr val="253B2C"/>
+                </a:solidFill>
+                <a:latin typeface="Calibri" pitchFamily="34" charset="0"/>
+                <a:ea typeface="Calibri" pitchFamily="34" charset="-122"/>
+                <a:cs typeface="Calibri" pitchFamily="34" charset="-120"/>
+              </a:rPr>
+              <a:t>A full UI redesign</a:t>
+            </a:r>
+            <a:endParaRPr lang="en-US" sz="1500" dirty="0"/>
           </a:p>
         </p:txBody>
       </p:sp>
@@ -3160,8 +3161,8 @@
         </p:nvSpPr>
         <p:spPr>
           <a:xfrm>
-            <a:off x="777240" y="3063240"/>
-            <a:ext cx="2491740" cy="822960"/>
+            <a:off x="868680" y="2871216"/>
+            <a:ext cx="5897880" cy="685800"/>
           </a:xfrm>
           <a:prstGeom prst="rect">
             <a:avLst/>
@@ -3175,42 +3176,22 @@
           <a:p>
             <a:pPr indent="0" marL="0">
               <a:lnSpc>
-                <a:spcPts val="1600"/>
-              </a:lnSpc>
-              <a:buNone/>
-            </a:pPr>
-            <a:r>
-              <a:rPr lang="en-US" sz="1250" dirty="0">
-                <a:solidFill>
-                  <a:srgbClr val="6B6354"/>
-                </a:solidFill>
-                <a:latin typeface="Calibri" pitchFamily="34" charset="0"/>
-                <a:ea typeface="Calibri" pitchFamily="34" charset="-122"/>
-                <a:cs typeface="Calibri" pitchFamily="34" charset="-120"/>
-              </a:rPr>
-              <a:t>lines of production</a:t>
-            </a:r>
-            <a:endParaRPr lang="en-US" sz="1250" dirty="0"/>
-          </a:p>
-          <a:p>
-            <a:pPr indent="0" marL="0">
-              <a:lnSpc>
-                <a:spcPts val="1600"/>
-              </a:lnSpc>
-              <a:buNone/>
-            </a:pPr>
-            <a:r>
-              <a:rPr lang="en-US" sz="1250" dirty="0">
-                <a:solidFill>
-                  <a:srgbClr val="6B6354"/>
-                </a:solidFill>
-                <a:latin typeface="Calibri" pitchFamily="34" charset="0"/>
-                <a:ea typeface="Calibri" pitchFamily="34" charset="-122"/>
-                <a:cs typeface="Calibri" pitchFamily="34" charset="-120"/>
-              </a:rPr>
-              <a:t>code, across 128 files</a:t>
-            </a:r>
-            <a:endParaRPr lang="en-US" sz="1250" dirty="0"/>
+                <a:spcPts val="1700"/>
+              </a:lnSpc>
+              <a:buNone/>
+            </a:pPr>
+            <a:r>
+              <a:rPr lang="en-US" sz="1300" dirty="0">
+                <a:solidFill>
+                  <a:srgbClr val="201D16"/>
+                </a:solidFill>
+                <a:latin typeface="Calibri" pitchFamily="34" charset="0"/>
+                <a:ea typeface="Calibri" pitchFamily="34" charset="-122"/>
+                <a:cs typeface="Calibri" pitchFamily="34" charset="-120"/>
+              </a:rPr>
+              <a:t>five rounds of design iteration, a mobile audit, fixes from testing on real phones</a:t>
+            </a:r>
+            <a:endParaRPr lang="en-US" sz="1300" dirty="0"/>
           </a:p>
         </p:txBody>
       </p:sp>
@@ -3222,23 +3203,16 @@
         </p:nvSpPr>
         <p:spPr>
           <a:xfrm>
-            <a:off x="3817620" y="2148840"/>
-            <a:ext cx="2948940" cy="1828800"/>
-          </a:xfrm>
-          <a:prstGeom prst="roundRect">
-            <a:avLst>
-              <a:gd name="adj" fmla="val 3000"/>
-            </a:avLst>
+            <a:off x="548640" y="3886200"/>
+            <a:ext cx="128016" cy="128016"/>
+          </a:xfrm>
+          <a:prstGeom prst="ellipse">
+            <a:avLst/>
           </a:prstGeom>
           <a:solidFill>
-            <a:srgbClr val="FFFDF8"/>
+            <a:srgbClr val="A8452A"/>
           </a:solidFill>
-          <a:ln w="12700">
-            <a:solidFill>
-              <a:srgbClr val="DCD0B4"/>
-            </a:solidFill>
-            <a:prstDash val="solid"/>
-          </a:ln>
+          <a:ln/>
         </p:spPr>
       </p:sp>
       <p:sp>
@@ -3249,8 +3223,8 @@
         </p:nvSpPr>
         <p:spPr>
           <a:xfrm>
-            <a:off x="4046220" y="2350008"/>
-            <a:ext cx="2491740" cy="685800"/>
+            <a:off x="868680" y="3758184"/>
+            <a:ext cx="5897880" cy="320040"/>
           </a:xfrm>
           <a:prstGeom prst="rect">
             <a:avLst/>
@@ -3266,17 +3240,17 @@
               <a:buNone/>
             </a:pPr>
             <a:r>
-              <a:rPr lang="en-US" sz="3200" b="1" dirty="0">
+              <a:rPr lang="en-US" sz="1500" b="1" dirty="0">
                 <a:solidFill>
                   <a:srgbClr val="253B2C"/>
                 </a:solidFill>
-                <a:latin typeface="Cambria" pitchFamily="34" charset="0"/>
-                <a:ea typeface="Cambria" pitchFamily="34" charset="-122"/>
-                <a:cs typeface="Cambria" pitchFamily="34" charset="-120"/>
-              </a:rPr>
-              <a:t>185</a:t>
-            </a:r>
-            <a:endParaRPr lang="en-US" sz="3200" dirty="0"/>
+                <a:latin typeface="Calibri" pitchFamily="34" charset="0"/>
+                <a:ea typeface="Calibri" pitchFamily="34" charset="-122"/>
+                <a:cs typeface="Calibri" pitchFamily="34" charset="-120"/>
+              </a:rPr>
+              <a:t>SEO from day one</a:t>
+            </a:r>
+            <a:endParaRPr lang="en-US" sz="1500" dirty="0"/>
           </a:p>
         </p:txBody>
       </p:sp>
@@ -3288,8 +3262,8 @@
         </p:nvSpPr>
         <p:spPr>
           <a:xfrm>
-            <a:off x="4046220" y="3063240"/>
-            <a:ext cx="2491740" cy="822960"/>
+            <a:off x="868680" y="4105656"/>
+            <a:ext cx="5897880" cy="685800"/>
           </a:xfrm>
           <a:prstGeom prst="rect">
             <a:avLst/>
@@ -3303,42 +3277,22 @@
           <a:p>
             <a:pPr indent="0" marL="0">
               <a:lnSpc>
-                <a:spcPts val="1600"/>
-              </a:lnSpc>
-              <a:buNone/>
-            </a:pPr>
-            <a:r>
-              <a:rPr lang="en-US" sz="1250" dirty="0">
-                <a:solidFill>
-                  <a:srgbClr val="6B6354"/>
-                </a:solidFill>
-                <a:latin typeface="Calibri" pitchFamily="34" charset="0"/>
-                <a:ea typeface="Calibri" pitchFamily="34" charset="-122"/>
-                <a:cs typeface="Calibri" pitchFamily="34" charset="-120"/>
-              </a:rPr>
-              <a:t>commits across</a:t>
-            </a:r>
-            <a:endParaRPr lang="en-US" sz="1250" dirty="0"/>
-          </a:p>
-          <a:p>
-            <a:pPr indent="0" marL="0">
-              <a:lnSpc>
-                <a:spcPts val="1600"/>
-              </a:lnSpc>
-              <a:buNone/>
-            </a:pPr>
-            <a:r>
-              <a:rPr lang="en-US" sz="1250" dirty="0">
-                <a:solidFill>
-                  <a:srgbClr val="6B6354"/>
-                </a:solidFill>
-                <a:latin typeface="Calibri" pitchFamily="34" charset="0"/>
-                <a:ea typeface="Calibri" pitchFamily="34" charset="-122"/>
-                <a:cs typeface="Calibri" pitchFamily="34" charset="-120"/>
-              </a:rPr>
-              <a:t>20 working branches</a:t>
-            </a:r>
-            <a:endParaRPr lang="en-US" sz="1250" dirty="0"/>
+                <a:spcPts val="1700"/>
+              </a:lnSpc>
+              <a:buNone/>
+            </a:pPr>
+            <a:r>
+              <a:rPr lang="en-US" sz="1300" dirty="0">
+                <a:solidFill>
+                  <a:srgbClr val="201D16"/>
+                </a:solidFill>
+                <a:latin typeface="Calibri" pitchFamily="34" charset="0"/>
+                <a:ea typeface="Calibri" pitchFamily="34" charset="-122"/>
+                <a:cs typeface="Calibri" pitchFamily="34" charset="-120"/>
+              </a:rPr>
+              <a:t>13 blog posts, structured data, a sitemap, Search Console</a:t>
+            </a:r>
+            <a:endParaRPr lang="en-US" sz="1300" dirty="0"/>
           </a:p>
         </p:txBody>
       </p:sp>
@@ -3350,23 +3304,16 @@
         </p:nvSpPr>
         <p:spPr>
           <a:xfrm>
-            <a:off x="548640" y="4297680"/>
-            <a:ext cx="2948940" cy="1828800"/>
-          </a:xfrm>
-          <a:prstGeom prst="roundRect">
-            <a:avLst>
-              <a:gd name="adj" fmla="val 3000"/>
-            </a:avLst>
+            <a:off x="548640" y="5120640"/>
+            <a:ext cx="128016" cy="128016"/>
+          </a:xfrm>
+          <a:prstGeom prst="ellipse">
+            <a:avLst/>
           </a:prstGeom>
           <a:solidFill>
-            <a:srgbClr val="FFFDF8"/>
+            <a:srgbClr val="A8452A"/>
           </a:solidFill>
-          <a:ln w="12700">
-            <a:solidFill>
-              <a:srgbClr val="DCD0B4"/>
-            </a:solidFill>
-            <a:prstDash val="solid"/>
-          </a:ln>
+          <a:ln/>
         </p:spPr>
       </p:sp>
       <p:sp>
@@ -3377,8 +3324,8 @@
         </p:nvSpPr>
         <p:spPr>
           <a:xfrm>
-            <a:off x="777240" y="4498848"/>
-            <a:ext cx="2491740" cy="685800"/>
+            <a:off x="868680" y="4992624"/>
+            <a:ext cx="5897880" cy="320040"/>
           </a:xfrm>
           <a:prstGeom prst="rect">
             <a:avLst/>
@@ -3394,17 +3341,17 @@
               <a:buNone/>
             </a:pPr>
             <a:r>
-              <a:rPr lang="en-US" sz="3200" b="1" dirty="0">
+              <a:rPr lang="en-US" sz="1500" b="1" dirty="0">
                 <a:solidFill>
                   <a:srgbClr val="253B2C"/>
                 </a:solidFill>
-                <a:latin typeface="Cambria" pitchFamily="34" charset="0"/>
-                <a:ea typeface="Cambria" pitchFamily="34" charset="-122"/>
-                <a:cs typeface="Cambria" pitchFamily="34" charset="-120"/>
-              </a:rPr>
-              <a:t>8+</a:t>
-            </a:r>
-            <a:endParaRPr lang="en-US" sz="3200" dirty="0"/>
+                <a:latin typeface="Calibri" pitchFamily="34" charset="0"/>
+                <a:ea typeface="Calibri" pitchFamily="34" charset="-122"/>
+                <a:cs typeface="Calibri" pitchFamily="34" charset="-120"/>
+              </a:rPr>
+              <a:t>A domain and trademark question</a:t>
+            </a:r>
+            <a:endParaRPr lang="en-US" sz="1500" dirty="0"/>
           </a:p>
         </p:txBody>
       </p:sp>
@@ -3416,8 +3363,8 @@
         </p:nvSpPr>
         <p:spPr>
           <a:xfrm>
-            <a:off x="777240" y="5212080"/>
-            <a:ext cx="2491740" cy="822960"/>
+            <a:off x="868680" y="5340096"/>
+            <a:ext cx="5897880" cy="685800"/>
           </a:xfrm>
           <a:prstGeom prst="rect">
             <a:avLst/>
@@ -3431,12 +3378,54 @@
           <a:p>
             <a:pPr indent="0" marL="0">
               <a:lnSpc>
-                <a:spcPts val="1600"/>
-              </a:lnSpc>
-              <a:buNone/>
-            </a:pPr>
-            <a:r>
-              <a:rPr lang="en-US" sz="1250" dirty="0">
+                <a:spcPts val="1700"/>
+              </a:lnSpc>
+              <a:buNone/>
+            </a:pPr>
+            <a:r>
+              <a:rPr lang="en-US" sz="1300" dirty="0">
+                <a:solidFill>
+                  <a:srgbClr val="201D16"/>
+                </a:solidFill>
+                <a:latin typeface="Calibri" pitchFamily="34" charset="0"/>
+                <a:ea typeface="Calibri" pitchFamily="34" charset="-122"/>
+                <a:cs typeface="Calibri" pitchFamily="34" charset="-120"/>
+              </a:rPr>
+              <a:t>worked through properly — a name collision found, checked, and resolved</a:t>
+            </a:r>
+            <a:endParaRPr lang="en-US" sz="1300" dirty="0"/>
+          </a:p>
+        </p:txBody>
+      </p:sp>
+      <p:sp>
+        <p:nvSpPr>
+          <p:cNvPr id="15" name="Text 12"/>
+          <p:cNvSpPr txBox="1"/>
+          <p:nvPr/>
+        </p:nvSpPr>
+        <p:spPr>
+          <a:xfrm>
+            <a:off x="548640" y="7955280"/>
+            <a:ext cx="6217920" cy="548640"/>
+          </a:xfrm>
+          <a:prstGeom prst="rect">
+            <a:avLst/>
+          </a:prstGeom>
+          <a:noFill/>
+          <a:ln/>
+        </p:spPr>
+        <p:txBody>
+          <a:bodyPr wrap="square" lIns="0" tIns="0" rIns="0" bIns="0" rtlCol="0" anchor="ctr"/>
+          <a:lstStyle/>
+          <a:p>
+            <a:pPr indent="0" marL="0">
+              <a:lnSpc>
+                <a:spcPts val="1700"/>
+              </a:lnSpc>
+              <a:buNone/>
+            </a:pPr>
+            <a:r>
+              <a:rPr lang="en-US" sz="1250" i="1" dirty="0">
                 <a:solidFill>
                   <a:srgbClr val="6B6354"/>
                 </a:solidFill>
@@ -3444,19 +3433,19 @@
                 <a:ea typeface="Calibri" pitchFamily="34" charset="-122"/>
                 <a:cs typeface="Calibri" pitchFamily="34" charset="-120"/>
               </a:rPr>
-              <a:t>production releases —</a:t>
+              <a:t>None of this is glamorous. All of it is why the site</a:t>
             </a:r>
             <a:endParaRPr lang="en-US" sz="1250" dirty="0"/>
           </a:p>
           <a:p>
             <a:pPr indent="0" marL="0">
               <a:lnSpc>
-                <a:spcPts val="1600"/>
-              </a:lnSpc>
-              <a:buNone/>
-            </a:pPr>
-            <a:r>
-              <a:rPr lang="en-US" sz="1250" dirty="0">
+                <a:spcPts val="1700"/>
+              </a:lnSpc>
+              <a:buNone/>
+            </a:pPr>
+            <a:r>
+              <a:rPr lang="en-US" sz="1250" i="1" dirty="0">
                 <a:solidFill>
                   <a:srgbClr val="6B6354"/>
                 </a:solidFill>
@@ -3464,7 +3453,7 @@
                 <a:ea typeface="Calibri" pitchFamily="34" charset="-122"/>
                 <a:cs typeface="Calibri" pitchFamily="34" charset="-120"/>
               </a:rPr>
-              <a:t>each one code-reviewed</a:t>
+              <a:t>works instead of just existing.</a:t>
             </a:r>
             <a:endParaRPr lang="en-US" sz="1250" dirty="0"/>
           </a:p>
@@ -3472,174 +3461,7 @@
       </p:sp>
       <p:sp>
         <p:nvSpPr>
-          <p:cNvPr id="15" name="Shape 12"/>
-          <p:cNvSpPr/>
-          <p:nvPr/>
-        </p:nvSpPr>
-        <p:spPr>
-          <a:xfrm>
-            <a:off x="3817620" y="4297680"/>
-            <a:ext cx="2948940" cy="1828800"/>
-          </a:xfrm>
-          <a:prstGeom prst="roundRect">
-            <a:avLst>
-              <a:gd name="adj" fmla="val 3000"/>
-            </a:avLst>
-          </a:prstGeom>
-          <a:solidFill>
-            <a:srgbClr val="FFFDF8"/>
-          </a:solidFill>
-          <a:ln w="12700">
-            <a:solidFill>
-              <a:srgbClr val="DCD0B4"/>
-            </a:solidFill>
-            <a:prstDash val="solid"/>
-          </a:ln>
-        </p:spPr>
-      </p:sp>
-      <p:sp>
-        <p:nvSpPr>
           <p:cNvPr id="16" name="Text 13"/>
-          <p:cNvSpPr txBox="1"/>
-          <p:nvPr/>
-        </p:nvSpPr>
-        <p:spPr>
-          <a:xfrm>
-            <a:off x="4046220" y="4498848"/>
-            <a:ext cx="2491740" cy="685800"/>
-          </a:xfrm>
-          <a:prstGeom prst="rect">
-            <a:avLst/>
-          </a:prstGeom>
-          <a:noFill/>
-          <a:ln/>
-        </p:spPr>
-        <p:txBody>
-          <a:bodyPr wrap="square" lIns="0" tIns="0" rIns="0" bIns="0" rtlCol="0" anchor="ctr"/>
-          <a:lstStyle/>
-          <a:p>
-            <a:pPr indent="0" marL="0">
-              <a:buNone/>
-            </a:pPr>
-            <a:r>
-              <a:rPr lang="en-US" sz="3200" b="1" dirty="0">
-                <a:solidFill>
-                  <a:srgbClr val="253B2C"/>
-                </a:solidFill>
-                <a:latin typeface="Cambria" pitchFamily="34" charset="0"/>
-                <a:ea typeface="Cambria" pitchFamily="34" charset="-122"/>
-                <a:cs typeface="Cambria" pitchFamily="34" charset="-120"/>
-              </a:rPr>
-              <a:t>13</a:t>
-            </a:r>
-            <a:endParaRPr lang="en-US" sz="3200" dirty="0"/>
-          </a:p>
-        </p:txBody>
-      </p:sp>
-      <p:sp>
-        <p:nvSpPr>
-          <p:cNvPr id="17" name="Text 14"/>
-          <p:cNvSpPr txBox="1"/>
-          <p:nvPr/>
-        </p:nvSpPr>
-        <p:spPr>
-          <a:xfrm>
-            <a:off x="4046220" y="5212080"/>
-            <a:ext cx="2491740" cy="822960"/>
-          </a:xfrm>
-          <a:prstGeom prst="rect">
-            <a:avLst/>
-          </a:prstGeom>
-          <a:noFill/>
-          <a:ln/>
-        </p:spPr>
-        <p:txBody>
-          <a:bodyPr wrap="square" lIns="0" tIns="0" rIns="0" bIns="0" rtlCol="0" anchor="ctr"/>
-          <a:lstStyle/>
-          <a:p>
-            <a:pPr indent="0" marL="0">
-              <a:lnSpc>
-                <a:spcPts val="1600"/>
-              </a:lnSpc>
-              <a:buNone/>
-            </a:pPr>
-            <a:r>
-              <a:rPr lang="en-US" sz="1250" dirty="0">
-                <a:solidFill>
-                  <a:srgbClr val="6B6354"/>
-                </a:solidFill>
-                <a:latin typeface="Calibri" pitchFamily="34" charset="0"/>
-                <a:ea typeface="Calibri" pitchFamily="34" charset="-122"/>
-                <a:cs typeface="Calibri" pitchFamily="34" charset="-120"/>
-              </a:rPr>
-              <a:t>SEO blog posts,</a:t>
-            </a:r>
-            <a:endParaRPr lang="en-US" sz="1250" dirty="0"/>
-          </a:p>
-          <a:p>
-            <a:pPr indent="0" marL="0">
-              <a:lnSpc>
-                <a:spcPts val="1600"/>
-              </a:lnSpc>
-              <a:buNone/>
-            </a:pPr>
-            <a:r>
-              <a:rPr lang="en-US" sz="1250" dirty="0">
-                <a:solidFill>
-                  <a:srgbClr val="6B6354"/>
-                </a:solidFill>
-                <a:latin typeface="Calibri" pitchFamily="34" charset="0"/>
-                <a:ea typeface="Calibri" pitchFamily="34" charset="-122"/>
-                <a:cs typeface="Calibri" pitchFamily="34" charset="-120"/>
-              </a:rPr>
-              <a:t>written and shipped</a:t>
-            </a:r>
-            <a:endParaRPr lang="en-US" sz="1250" dirty="0"/>
-          </a:p>
-        </p:txBody>
-      </p:sp>
-      <p:sp>
-        <p:nvSpPr>
-          <p:cNvPr id="18" name="Text 15"/>
-          <p:cNvSpPr txBox="1"/>
-          <p:nvPr/>
-        </p:nvSpPr>
-        <p:spPr>
-          <a:xfrm>
-            <a:off x="548640" y="8092440"/>
-            <a:ext cx="6217920" cy="365760"/>
-          </a:xfrm>
-          <a:prstGeom prst="rect">
-            <a:avLst/>
-          </a:prstGeom>
-          <a:noFill/>
-          <a:ln/>
-        </p:spPr>
-        <p:txBody>
-          <a:bodyPr wrap="square" lIns="0" tIns="0" rIns="0" bIns="0" rtlCol="0" anchor="ctr"/>
-          <a:lstStyle/>
-          <a:p>
-            <a:pPr indent="0" marL="0">
-              <a:buNone/>
-            </a:pPr>
-            <a:r>
-              <a:rPr lang="en-US" sz="1250" i="1" dirty="0">
-                <a:solidFill>
-                  <a:srgbClr val="6B6354"/>
-                </a:solidFill>
-                <a:latin typeface="Calibri" pitchFamily="34" charset="0"/>
-                <a:ea typeface="Calibri" pitchFamily="34" charset="-122"/>
-                <a:cs typeface="Calibri" pitchFamily="34" charset="-120"/>
-              </a:rPr>
-              <a:t>Every line reviewed and directed by a human — not autopilot.</a:t>
-            </a:r>
-            <a:endParaRPr lang="en-US" sz="1250" dirty="0"/>
-          </a:p>
-        </p:txBody>
-      </p:sp>
-      <p:sp>
-        <p:nvSpPr>
-          <p:cNvPr id="19" name="Text 16"/>
           <p:cNvSpPr txBox="1"/>
           <p:nvPr/>
         </p:nvSpPr>
@@ -4335,7 +4157,7 @@
         <p:spPr>
           <a:xfrm>
             <a:off x="548640" y="6492240"/>
-            <a:ext cx="6217920" cy="1371600"/>
+            <a:ext cx="6217920" cy="777240"/>
           </a:xfrm>
           <a:prstGeom prst="rect">
             <a:avLst/>
@@ -4382,35 +4204,97 @@
                 <a:ea typeface="Calibri" pitchFamily="34" charset="-122"/>
                 <a:cs typeface="Calibri" pitchFamily="34" charset="-120"/>
               </a:rPr>
-              <a:t>“personalisation” was cosmetic, not structural. That's</a:t>
+              <a:t>“personalisation” was cosmetic, not structural.</a:t>
             </a:r>
             <a:endParaRPr lang="en-US" sz="1450" dirty="0"/>
           </a:p>
+        </p:txBody>
+      </p:sp>
+      <p:sp>
+        <p:nvSpPr>
+          <p:cNvPr id="17" name="Text 14"/>
+          <p:cNvSpPr txBox="1"/>
+          <p:nvPr/>
+        </p:nvSpPr>
+        <p:spPr>
+          <a:xfrm>
+            <a:off x="548640" y="7315200"/>
+            <a:ext cx="6217920" cy="1097280"/>
+          </a:xfrm>
+          <a:prstGeom prst="rect">
+            <a:avLst/>
+          </a:prstGeom>
+          <a:noFill/>
+          <a:ln/>
+        </p:spPr>
+        <p:txBody>
+          <a:bodyPr wrap="square" lIns="0" tIns="0" rIns="0" bIns="0" rtlCol="0" anchor="ctr"/>
+          <a:lstStyle/>
           <a:p>
             <a:pPr indent="0" marL="0">
               <a:lnSpc>
-                <a:spcPts val="2000"/>
-              </a:lnSpc>
-              <a:buNone/>
-            </a:pPr>
-            <a:r>
-              <a:rPr lang="en-US" sz="1450" dirty="0">
-                <a:solidFill>
-                  <a:srgbClr val="201D16"/>
-                </a:solidFill>
-                <a:latin typeface="Calibri" pitchFamily="34" charset="0"/>
-                <a:ea typeface="Calibri" pitchFamily="34" charset="-122"/>
-                <a:cs typeface="Calibri" pitchFamily="34" charset="-120"/>
-              </a:rPr>
-              <a:t>months of customer feedback, surfaced in an afternoon.</a:t>
-            </a:r>
-            <a:endParaRPr lang="en-US" sz="1450" dirty="0"/>
-          </a:p>
-        </p:txBody>
-      </p:sp>
-      <p:sp>
-        <p:nvSpPr>
-          <p:cNvPr id="17" name="Text 14"/>
+                <a:spcPts val="1700"/>
+              </a:lnSpc>
+              <a:buNone/>
+            </a:pPr>
+            <a:r>
+              <a:rPr lang="en-US" sz="1250" i="1" dirty="0">
+                <a:solidFill>
+                  <a:srgbClr val="6B6354"/>
+                </a:solidFill>
+                <a:latin typeface="Calibri" pitchFamily="34" charset="0"/>
+                <a:ea typeface="Calibri" pitchFamily="34" charset="-122"/>
+                <a:cs typeface="Calibri" pitchFamily="34" charset="-120"/>
+              </a:rPr>
+              <a:t>It's not a substitute for real customer feedback — I still</a:t>
+            </a:r>
+            <a:endParaRPr lang="en-US" sz="1250" dirty="0"/>
+          </a:p>
+          <a:p>
+            <a:pPr indent="0" marL="0">
+              <a:lnSpc>
+                <a:spcPts val="1700"/>
+              </a:lnSpc>
+              <a:buNone/>
+            </a:pPr>
+            <a:r>
+              <a:rPr lang="en-US" sz="1250" i="1" dirty="0">
+                <a:solidFill>
+                  <a:srgbClr val="6B6354"/>
+                </a:solidFill>
+                <a:latin typeface="Calibri" pitchFamily="34" charset="0"/>
+                <a:ea typeface="Calibri" pitchFamily="34" charset="-122"/>
+                <a:cs typeface="Calibri" pitchFamily="34" charset="-120"/>
+              </a:rPr>
+              <a:t>ask real parents directly, too. Together: a fast first pass,</a:t>
+            </a:r>
+            <a:endParaRPr lang="en-US" sz="1250" dirty="0"/>
+          </a:p>
+          <a:p>
+            <a:pPr indent="0" marL="0">
+              <a:lnSpc>
+                <a:spcPts val="1700"/>
+              </a:lnSpc>
+              <a:buNone/>
+            </a:pPr>
+            <a:r>
+              <a:rPr lang="en-US" sz="1250" i="1" dirty="0">
+                <a:solidFill>
+                  <a:srgbClr val="6B6354"/>
+                </a:solidFill>
+                <a:latin typeface="Calibri" pitchFamily="34" charset="0"/>
+                <a:ea typeface="Calibri" pitchFamily="34" charset="-122"/>
+                <a:cs typeface="Calibri" pitchFamily="34" charset="-120"/>
+              </a:rPr>
+              <a:t>and a real check.</a:t>
+            </a:r>
+            <a:endParaRPr lang="en-US" sz="1250" dirty="0"/>
+          </a:p>
+        </p:txBody>
+      </p:sp>
+      <p:sp>
+        <p:nvSpPr>
+          <p:cNvPr id="18" name="Text 15"/>
           <p:cNvSpPr txBox="1"/>
           <p:nvPr/>
         </p:nvSpPr>
@@ -6007,7 +5891,7 @@
                 <a:ea typeface="Calibri" pitchFamily="34" charset="-122"/>
                 <a:cs typeface="Calibri" pitchFamily="34" charset="-120"/>
               </a:rPr>
-              <a:t>parents — and build it as a genuine passive-income</a:t>
+              <a:t>parents — and build a content-driven income stream</a:t>
             </a:r>
             <a:endParaRPr lang="en-US" sz="1400" dirty="0"/>
           </a:p>
@@ -6027,7 +5911,7 @@
                 <a:ea typeface="Calibri" pitchFamily="34" charset="-122"/>
                 <a:cs typeface="Calibri" pitchFamily="34" charset="-120"/>
               </a:rPr>
-              <a:t>stream along the way.</a:t>
+              <a:t>along the way. Not passive: it takes ongoing work.</a:t>
             </a:r>
             <a:endParaRPr lang="en-US" sz="1400" dirty="0"/>
           </a:p>

</xml_diff>